<commit_message>
Câu chuyện distillation flywheel: LLM bootstrap PyTorch — PITCH Q&A + README kiến trúc + slide pilot & notes deck
Co-Authored-By: Claude Fable 5 <noreply@anthropic.com>
</commit_message>
<xml_diff>
--- a/docs/DocFlow-pitch-DemoDay.pptx
+++ b/docs/DocFlow-pitch-DemoDay.pptx
@@ -1142,7 +1142,7 @@
           <a:lstStyle/>
           <a:p>
             <a:r>
-              <a:t>Với giải META: PyTorch không gắn vào cho có. Nó là bộ định tuyến đứng đầu pipeline — train tại sự kiện, dataset sinh lại được bằng script, TorchScript serve production. Camera thấy chip PyTorch trên từng chứng từ trong UI.</a:t>
+              <a:t>Với giải META: PyTorch không gắn vào cho có. Nó là bộ định tuyến đứng đầu pipeline — train tại sự kiện, dataset sinh lại được bằng script, TorchScript serve production. Camera thấy chip PyTorch trên từng chứng từ trong UI. Nếu bị hỏi 'sao không PyTorch toàn phần cho rẻ': hôm nay AI đắt nhất giá 500đ/bộ — vấn đề không phải model rẻ mà là dữ liệu train. Mỗi trường người duyệt = 1 nhãn ground truth kèm bbox; 3 tháng pilot = vài trăm nghìn nhãn → distill từng loại chứng từ layout ổn định sang extractor PyTorch on-prem, Gemini rút về làm lưới an toàn ca khó. 'Tụi em không chọn giữa LLM và PyTorch — tụi em dùng LLM để bootstrap PyTorch.'</a:t>
             </a:r>
           </a:p>
         </p:txBody>
@@ -5192,7 +5192,7 @@
                 </a:solidFill>
                 <a:latin typeface="Arial"/>
               </a:rPr>
-              <a:t>Mở rộng loại chứng từ (SWIFT/TT full, BCTC doanh nghiệp), lớp verify OCR độc lập, rollout theo cụm chi nhánh</a:t>
+              <a:t>Distill sang extractor PyTorch chuyên biệt chạy on-prem — nhãn lấy từ chính review queue, dữ liệu không rời ngân hàng, chi phí biên tiệm cận 0</a:t>
             </a:r>
           </a:p>
         </p:txBody>

</xml_diff>

<commit_message>
Deck: thêm slide 9 flywheel distillation (vòng 4 bước + 3 payoff + quote), business/pilot dời số 10-11 — 12 slide
Co-Authored-By: Claude Fable 5 <noreply@anthropic.com>
</commit_message>
<xml_diff>
--- a/docs/DocFlow-pitch-DemoDay.pptx
+++ b/docs/DocFlow-pitch-DemoDay.pptx
@@ -16,6 +16,7 @@
     <p:sldId id="264" r:id="rId16"/>
     <p:sldId id="265" r:id="rId17"/>
     <p:sldId id="266" r:id="rId18"/>
+    <p:sldId id="267" r:id="rId19"/>
   </p:sldIdLst>
   <p:sldSz cx="12191695" cy="6858000" type="screen4x3"/>
   <p:notesSz cx="6858000" cy="9144000"/>
@@ -582,7 +583,7 @@
           <a:lstStyle/>
           <a:p>
             <a:r>
-              <a:t>Chốt: 2 tuần sau hôm nay tụi em có thể chạy sandbox trên hồ sơ ẩn danh. 3 tháng pilot một chi nhánh với KPI 70% trường tự động. Câu kết: DocFlow không phải demo hackathon — nó là sản phẩm SHB có thể bật công tắc.</a:t>
+              <a:t>Ba nguồn thu: phí theo lượt, phí tích hợp một lần, thuê bao vận hành theo chi nhánh. Đơn vị kinh tế minh bạch: 10.000 bộ/tháng tốn khoảng 5 triệu đồng AI. Sản phẩm không phụ thuộc SHB — lõi IDP dùng được cho mọi tổ chức tài chính.</a:t>
             </a:r>
           </a:p>
         </p:txBody>
@@ -652,6 +653,76 @@
           <a:lstStyle/>
           <a:p>
             <a:r>
+              <a:t>Chốt: 2 tuần sau hôm nay tụi em có thể chạy sandbox trên hồ sơ ẩn danh. 3 tháng pilot một chi nhánh với KPI 70% trường tự động. Câu kết: DocFlow không phải demo hackathon — nó là sản phẩm SHB có thể bật công tắc.</a:t>
+            </a:r>
+          </a:p>
+        </p:txBody>
+      </p:sp>
+      <p:sp>
+        <p:nvSpPr>
+          <p:cNvPr id="4" name="Slide Number Placeholder 3"/>
+          <p:cNvSpPr>
+            <a:spLocks noGrp="1"/>
+          </p:cNvSpPr>
+          <p:nvPr>
+            <p:ph type="sldNum" idx="5" sz="quarter"/>
+          </p:nvPr>
+        </p:nvSpPr>
+        <p:spPr/>
+      </p:sp>
+    </p:spTree>
+  </p:cSld>
+  <p:clrMapOvr>
+    <a:masterClrMapping/>
+  </p:clrMapOvr>
+</p:notes>
+</file>
+
+<file path=ppt/notesSlides/notesSlide12.xml><?xml version="1.0" encoding="utf-8"?>
+<p:notes xmlns:a="http://schemas.openxmlformats.org/drawingml/2006/main" xmlns:p="http://schemas.openxmlformats.org/presentationml/2006/main" xmlns:r="http://schemas.openxmlformats.org/officeDocument/2006/relationships">
+  <p:cSld>
+    <p:spTree>
+      <p:nvGrpSpPr>
+        <p:cNvPr id="1" name=""/>
+        <p:cNvGrpSpPr/>
+        <p:nvPr/>
+      </p:nvGrpSpPr>
+      <p:grpSpPr>
+        <a:xfrm>
+          <a:off x="0" y="0"/>
+          <a:ext cx="0" cy="0"/>
+          <a:chOff x="0" y="0"/>
+          <a:chExt cx="0" cy="0"/>
+        </a:xfrm>
+      </p:grpSpPr>
+      <p:sp>
+        <p:nvSpPr>
+          <p:cNvPr id="2" name="Slide Image Placeholder 1"/>
+          <p:cNvSpPr>
+            <a:spLocks noGrp="1"/>
+          </p:cNvSpPr>
+          <p:nvPr>
+            <p:ph type="sldImg" idx="2"/>
+          </p:nvPr>
+        </p:nvSpPr>
+        <p:spPr/>
+      </p:sp>
+      <p:sp>
+        <p:nvSpPr>
+          <p:cNvPr id="3" name="Notes Placeholder 2"/>
+          <p:cNvSpPr>
+            <a:spLocks noGrp="1"/>
+          </p:cNvSpPr>
+          <p:nvPr>
+            <p:ph type="body" idx="3" sz="quarter"/>
+          </p:nvPr>
+        </p:nvSpPr>
+        <p:spPr/>
+        <p:txBody>
+          <a:bodyPr/>
+          <a:lstStyle/>
+          <a:p>
+            <a:r>
               <a:t>Q&amp;A tủ: (1) Sai thì sao → review queue + audit. (2) AI sai cả hai bản → nhập tay áp mọi nguồn, vẫn audit. (3) Tích hợp core Intellect 2010 → adapter qua ESB, không đụng core. (4) Sao không để AI tự đối chiếu → trọng tài phải deterministic. (5) Bảo mật → access code, RLS, private bucket. (6) Scale → serverless, 10.000 bộ/ngày ≈ 5 triệu đồng AI.</a:t>
             </a:r>
           </a:p>
@@ -1212,7 +1283,7 @@
           <a:lstStyle/>
           <a:p>
             <a:r>
-              <a:t>Ba nguồn thu: phí theo lượt, phí tích hợp một lần, thuê bao vận hành theo chi nhánh. Đơn vị kinh tế minh bạch: 10.000 bộ/tháng tốn khoảng 5 triệu đồng AI. Sản phẩm không phụ thuộc SHB — lõi IDP dùng được cho mọi tổ chức tài chính.</a:t>
+              <a:t>Slide phản công chủ động khi Q&amp;A chạm chi phí/phụ thuộc Gemini. Hôm nay AI đắt nhất giá 500 đồng/bộ — vấn đề không phải model rẻ mà là dữ liệu train. Review queue chính là dây chuyền gán nhãn: 10k bộ/tháng × 15 trường × 4 chứng từ ≈ nửa triệu nhãn/tháng. 3 tháng pilot đủ distill extractor riêng cho CCCD, MT103 — chạy on-prem trong SHB. Không công ty AI nào mua được dataset đó — chỉ vận hành thật mới sinh ra. Đó là moat.</a:t>
             </a:r>
           </a:p>
         </p:txBody>
@@ -4731,7 +4802,7 @@
                 </a:solidFill>
                 <a:latin typeface="Arial"/>
               </a:rPr>
-              <a:t>PILOT PATHWAY</a:t>
+              <a:t>BUSINESS MODEL</a:t>
             </a:r>
           </a:p>
         </p:txBody>
@@ -4773,7 +4844,7 @@
                 </a:solidFill>
                 <a:latin typeface="Arial"/>
               </a:rPr>
-              <a:t>Lộ trình pilot — bật công tắc là chạy</a:t>
+              <a:t>Mô hình kinh doanh</a:t>
             </a:r>
           </a:p>
         </p:txBody>
@@ -4914,16 +4985,62 @@
         </p:nvSpPr>
         <p:spPr>
           <a:xfrm>
-            <a:off x="502920" y="1737360"/>
-            <a:ext cx="1554480" cy="914400"/>
+            <a:off x="502920" y="1645920"/>
+            <a:ext cx="3657600" cy="2651760"/>
           </a:xfrm>
           <a:prstGeom prst="roundRect">
             <a:avLst>
-              <a:gd name="adj" fmla="val 14000"/>
+              <a:gd name="adj" fmla="val 6000"/>
             </a:avLst>
           </a:prstGeom>
           <a:solidFill>
-            <a:srgbClr val="0E1F3D"/>
+            <a:srgbClr val="FFFFFF"/>
+          </a:solidFill>
+          <a:ln w="12700">
+            <a:solidFill>
+              <a:srgbClr val="E3E8F2"/>
+            </a:solidFill>
+          </a:ln>
+          <a:effectLst/>
+        </p:spPr>
+        <p:style>
+          <a:lnRef idx="1">
+            <a:schemeClr val="accent1"/>
+          </a:lnRef>
+          <a:fillRef idx="3">
+            <a:schemeClr val="accent1"/>
+          </a:fillRef>
+          <a:effectRef idx="2">
+            <a:schemeClr val="accent1"/>
+          </a:effectRef>
+          <a:fontRef idx="minor">
+            <a:schemeClr val="lt1"/>
+          </a:fontRef>
+        </p:style>
+        <p:txBody>
+          <a:bodyPr rtlCol="0" anchor="ctr"/>
+          <a:lstStyle/>
+          <a:p>
+            <a:pPr algn="ctr"/>
+          </a:p>
+        </p:txBody>
+      </p:sp>
+      <p:sp>
+        <p:nvSpPr>
+          <p:cNvPr id="10" name="Rectangle 9"/>
+          <p:cNvSpPr/>
+          <p:nvPr/>
+        </p:nvSpPr>
+        <p:spPr>
+          <a:xfrm>
+            <a:off x="502920" y="1645920"/>
+            <a:ext cx="3657600" cy="128016"/>
+          </a:xfrm>
+          <a:prstGeom prst="rect">
+            <a:avLst/>
+          </a:prstGeom>
+          <a:solidFill>
+            <a:srgbClr val="C25605"/>
           </a:solidFill>
           <a:ln>
             <a:noFill/>
@@ -4949,28 +5066,19 @@
           <a:lstStyle/>
           <a:p>
             <a:pPr algn="ctr"/>
-            <a:r>
-              <a:rPr sz="1700" b="1">
-                <a:solidFill>
-                  <a:srgbClr val="FFFFFF"/>
-                </a:solidFill>
-                <a:latin typeface="Arial"/>
-              </a:rPr>
-              <a:t>2 tuần</a:t>
-            </a:r>
-          </a:p>
-        </p:txBody>
-      </p:sp>
-      <p:sp>
-        <p:nvSpPr>
-          <p:cNvPr id="10" name="TextBox 9"/>
+          </a:p>
+        </p:txBody>
+      </p:sp>
+      <p:sp>
+        <p:nvSpPr>
+          <p:cNvPr id="11" name="TextBox 10"/>
           <p:cNvSpPr txBox="1"/>
           <p:nvPr/>
         </p:nvSpPr>
         <p:spPr>
           <a:xfrm>
-            <a:off x="2331720" y="1847088"/>
-            <a:ext cx="9326880" cy="822960"/>
+            <a:off x="777240" y="1965960"/>
+            <a:ext cx="3108960" cy="548640"/>
           </a:xfrm>
           <a:prstGeom prst="rect">
             <a:avLst/>
@@ -4984,290 +5092,6 @@
           <a:lstStyle/>
           <a:p>
             <a:pPr algn="l">
-              <a:lnSpc>
-                <a:spcPct val="110000"/>
-              </a:lnSpc>
-              <a:spcAft>
-                <a:spcPts val="600"/>
-              </a:spcAft>
-            </a:pPr>
-            <a:r>
-              <a:rPr sz="1550" b="0" i="0">
-                <a:solidFill>
-                  <a:srgbClr val="0E1F3D"/>
-                </a:solidFill>
-                <a:latin typeface="Arial"/>
-              </a:rPr>
-              <a:t>Sandbox trên hồ sơ ẩn danh SHB — đo accuracy trên dữ liệu thật của ngân hàng</a:t>
-            </a:r>
-          </a:p>
-        </p:txBody>
-      </p:sp>
-      <p:sp>
-        <p:nvSpPr>
-          <p:cNvPr id="11" name="Rounded Rectangle 10"/>
-          <p:cNvSpPr/>
-          <p:nvPr/>
-        </p:nvSpPr>
-        <p:spPr>
-          <a:xfrm>
-            <a:off x="502920" y="2880360"/>
-            <a:ext cx="1554480" cy="914400"/>
-          </a:xfrm>
-          <a:prstGeom prst="roundRect">
-            <a:avLst>
-              <a:gd name="adj" fmla="val 14000"/>
-            </a:avLst>
-          </a:prstGeom>
-          <a:solidFill>
-            <a:srgbClr val="0E1F3D"/>
-          </a:solidFill>
-          <a:ln>
-            <a:noFill/>
-          </a:ln>
-          <a:effectLst/>
-        </p:spPr>
-        <p:style>
-          <a:lnRef idx="1">
-            <a:schemeClr val="accent1"/>
-          </a:lnRef>
-          <a:fillRef idx="3">
-            <a:schemeClr val="accent1"/>
-          </a:fillRef>
-          <a:effectRef idx="2">
-            <a:schemeClr val="accent1"/>
-          </a:effectRef>
-          <a:fontRef idx="minor">
-            <a:schemeClr val="lt1"/>
-          </a:fontRef>
-        </p:style>
-        <p:txBody>
-          <a:bodyPr rtlCol="0" anchor="ctr"/>
-          <a:lstStyle/>
-          <a:p>
-            <a:pPr algn="ctr"/>
-            <a:r>
-              <a:rPr sz="1700" b="1">
-                <a:solidFill>
-                  <a:srgbClr val="FFFFFF"/>
-                </a:solidFill>
-                <a:latin typeface="Arial"/>
-              </a:rPr>
-              <a:t>3 tháng</a:t>
-            </a:r>
-          </a:p>
-        </p:txBody>
-      </p:sp>
-      <p:sp>
-        <p:nvSpPr>
-          <p:cNvPr id="12" name="TextBox 11"/>
-          <p:cNvSpPr txBox="1"/>
-          <p:nvPr/>
-        </p:nvSpPr>
-        <p:spPr>
-          <a:xfrm>
-            <a:off x="2331720" y="2990088"/>
-            <a:ext cx="9326880" cy="822960"/>
-          </a:xfrm>
-          <a:prstGeom prst="rect">
-            <a:avLst/>
-          </a:prstGeom>
-          <a:noFill/>
-        </p:spPr>
-        <p:txBody>
-          <a:bodyPr wrap="square" anchor="t" lIns="0" rIns="0" tIns="0" bIns="0">
-            <a:spAutoFit/>
-          </a:bodyPr>
-          <a:lstStyle/>
-          <a:p>
-            <a:pPr algn="l">
-              <a:lnSpc>
-                <a:spcPct val="110000"/>
-              </a:lnSpc>
-              <a:spcAft>
-                <a:spcPts val="600"/>
-              </a:spcAft>
-            </a:pPr>
-            <a:r>
-              <a:rPr sz="1550" b="0" i="0">
-                <a:solidFill>
-                  <a:srgbClr val="0E1F3D"/>
-                </a:solidFill>
-                <a:latin typeface="Arial"/>
-              </a:rPr>
-              <a:t>Pilot một chi nhánh, luồng vay cá nhân — KPI: 70% trường tự động, đo thời gian tiết kiệm</a:t>
-            </a:r>
-          </a:p>
-        </p:txBody>
-      </p:sp>
-      <p:sp>
-        <p:nvSpPr>
-          <p:cNvPr id="13" name="Rounded Rectangle 12"/>
-          <p:cNvSpPr/>
-          <p:nvPr/>
-        </p:nvSpPr>
-        <p:spPr>
-          <a:xfrm>
-            <a:off x="502920" y="4023360"/>
-            <a:ext cx="1554480" cy="914400"/>
-          </a:xfrm>
-          <a:prstGeom prst="roundRect">
-            <a:avLst>
-              <a:gd name="adj" fmla="val 14000"/>
-            </a:avLst>
-          </a:prstGeom>
-          <a:solidFill>
-            <a:srgbClr val="0E1F3D"/>
-          </a:solidFill>
-          <a:ln>
-            <a:noFill/>
-          </a:ln>
-          <a:effectLst/>
-        </p:spPr>
-        <p:style>
-          <a:lnRef idx="1">
-            <a:schemeClr val="accent1"/>
-          </a:lnRef>
-          <a:fillRef idx="3">
-            <a:schemeClr val="accent1"/>
-          </a:fillRef>
-          <a:effectRef idx="2">
-            <a:schemeClr val="accent1"/>
-          </a:effectRef>
-          <a:fontRef idx="minor">
-            <a:schemeClr val="lt1"/>
-          </a:fontRef>
-        </p:style>
-        <p:txBody>
-          <a:bodyPr rtlCol="0" anchor="ctr"/>
-          <a:lstStyle/>
-          <a:p>
-            <a:pPr algn="ctr"/>
-            <a:r>
-              <a:rPr sz="1700" b="1">
-                <a:solidFill>
-                  <a:srgbClr val="FFFFFF"/>
-                </a:solidFill>
-                <a:latin typeface="Arial"/>
-              </a:rPr>
-              <a:t>6 tháng</a:t>
-            </a:r>
-          </a:p>
-        </p:txBody>
-      </p:sp>
-      <p:sp>
-        <p:nvSpPr>
-          <p:cNvPr id="14" name="TextBox 13"/>
-          <p:cNvSpPr txBox="1"/>
-          <p:nvPr/>
-        </p:nvSpPr>
-        <p:spPr>
-          <a:xfrm>
-            <a:off x="2331720" y="4133088"/>
-            <a:ext cx="9326880" cy="822960"/>
-          </a:xfrm>
-          <a:prstGeom prst="rect">
-            <a:avLst/>
-          </a:prstGeom>
-          <a:noFill/>
-        </p:spPr>
-        <p:txBody>
-          <a:bodyPr wrap="square" anchor="t" lIns="0" rIns="0" tIns="0" bIns="0">
-            <a:spAutoFit/>
-          </a:bodyPr>
-          <a:lstStyle/>
-          <a:p>
-            <a:pPr algn="l">
-              <a:lnSpc>
-                <a:spcPct val="110000"/>
-              </a:lnSpc>
-              <a:spcAft>
-                <a:spcPts val="600"/>
-              </a:spcAft>
-            </a:pPr>
-            <a:r>
-              <a:rPr sz="1550" b="0" i="0">
-                <a:solidFill>
-                  <a:srgbClr val="0E1F3D"/>
-                </a:solidFill>
-                <a:latin typeface="Arial"/>
-              </a:rPr>
-              <a:t>Distill sang extractor PyTorch chuyên biệt chạy on-prem — nhãn lấy từ chính review queue, dữ liệu không rời ngân hàng, chi phí biên tiệm cận 0</a:t>
-            </a:r>
-          </a:p>
-        </p:txBody>
-      </p:sp>
-      <p:sp>
-        <p:nvSpPr>
-          <p:cNvPr id="15" name="Rounded Rectangle 14"/>
-          <p:cNvSpPr/>
-          <p:nvPr/>
-        </p:nvSpPr>
-        <p:spPr>
-          <a:xfrm>
-            <a:off x="502920" y="5212080"/>
-            <a:ext cx="11201400" cy="1051560"/>
-          </a:xfrm>
-          <a:prstGeom prst="roundRect">
-            <a:avLst>
-              <a:gd name="adj" fmla="val 10000"/>
-            </a:avLst>
-          </a:prstGeom>
-          <a:solidFill>
-            <a:srgbClr val="FFF7E6"/>
-          </a:solidFill>
-          <a:ln w="15240">
-            <a:solidFill>
-              <a:srgbClr val="F58220"/>
-            </a:solidFill>
-          </a:ln>
-          <a:effectLst/>
-        </p:spPr>
-        <p:style>
-          <a:lnRef idx="1">
-            <a:schemeClr val="accent1"/>
-          </a:lnRef>
-          <a:fillRef idx="3">
-            <a:schemeClr val="accent1"/>
-          </a:fillRef>
-          <a:effectRef idx="2">
-            <a:schemeClr val="accent1"/>
-          </a:effectRef>
-          <a:fontRef idx="minor">
-            <a:schemeClr val="lt1"/>
-          </a:fontRef>
-        </p:style>
-        <p:txBody>
-          <a:bodyPr rtlCol="0" anchor="ctr"/>
-          <a:lstStyle/>
-          <a:p>
-            <a:pPr algn="ctr"/>
-          </a:p>
-        </p:txBody>
-      </p:sp>
-      <p:sp>
-        <p:nvSpPr>
-          <p:cNvPr id="16" name="TextBox 15"/>
-          <p:cNvSpPr txBox="1"/>
-          <p:nvPr/>
-        </p:nvSpPr>
-        <p:spPr>
-          <a:xfrm>
-            <a:off x="868680" y="5431536"/>
-            <a:ext cx="10515600" cy="731520"/>
-          </a:xfrm>
-          <a:prstGeom prst="rect">
-            <a:avLst/>
-          </a:prstGeom>
-          <a:noFill/>
-        </p:spPr>
-        <p:txBody>
-          <a:bodyPr wrap="square" anchor="t" lIns="0" rIns="0" tIns="0" bIns="0">
-            <a:spAutoFit/>
-          </a:bodyPr>
-          <a:lstStyle/>
-          <a:p>
-            <a:pPr algn="ctr">
               <a:lnSpc>
                 <a:spcPct val="100000"/>
               </a:lnSpc>
@@ -5276,13 +5100,486 @@
               </a:spcAft>
             </a:pPr>
             <a:r>
-              <a:rPr sz="1900" b="1" i="0">
-                <a:solidFill>
-                  <a:srgbClr val="C25605"/>
-                </a:solidFill>
-                <a:latin typeface="Arial"/>
-              </a:rPr>
-              <a:t>“DocFlow không phải demo hackathon — nó là sản phẩm SHB có thể bật công tắc.”</a:t>
+              <a:rPr sz="1700" b="1" i="0">
+                <a:solidFill>
+                  <a:srgbClr val="0E1F3D"/>
+                </a:solidFill>
+                <a:latin typeface="Arial"/>
+              </a:rPr>
+              <a:t>Phí theo bộ hồ sơ</a:t>
+            </a:r>
+          </a:p>
+        </p:txBody>
+      </p:sp>
+      <p:sp>
+        <p:nvSpPr>
+          <p:cNvPr id="12" name="TextBox 11"/>
+          <p:cNvSpPr txBox="1"/>
+          <p:nvPr/>
+        </p:nvSpPr>
+        <p:spPr>
+          <a:xfrm>
+            <a:off x="777240" y="2514600"/>
+            <a:ext cx="3108960" cy="1645920"/>
+          </a:xfrm>
+          <a:prstGeom prst="rect">
+            <a:avLst/>
+          </a:prstGeom>
+          <a:noFill/>
+        </p:spPr>
+        <p:txBody>
+          <a:bodyPr wrap="square" anchor="t" lIns="0" rIns="0" tIns="0" bIns="0">
+            <a:spAutoFit/>
+          </a:bodyPr>
+          <a:lstStyle/>
+          <a:p>
+            <a:pPr algn="l">
+              <a:lnSpc>
+                <a:spcPct val="112000"/>
+              </a:lnSpc>
+              <a:spcAft>
+                <a:spcPts val="600"/>
+              </a:spcAft>
+            </a:pPr>
+            <a:r>
+              <a:rPr sz="1350" b="0" i="0">
+                <a:solidFill>
+                  <a:srgbClr val="51617F"/>
+                </a:solidFill>
+                <a:latin typeface="Arial"/>
+              </a:rPr>
+              <a:t>Thu theo lượt xử lý (SaaS). Chi phí AI &lt; 500đ/bộ — giá bán vài nghìn đồng vẫn rẻ hơn nhiều lần chi phí giờ công nhập tay.</a:t>
+            </a:r>
+          </a:p>
+        </p:txBody>
+      </p:sp>
+      <p:sp>
+        <p:nvSpPr>
+          <p:cNvPr id="13" name="Rounded Rectangle 12"/>
+          <p:cNvSpPr/>
+          <p:nvPr/>
+        </p:nvSpPr>
+        <p:spPr>
+          <a:xfrm>
+            <a:off x="4270248" y="1645920"/>
+            <a:ext cx="3657600" cy="2651760"/>
+          </a:xfrm>
+          <a:prstGeom prst="roundRect">
+            <a:avLst>
+              <a:gd name="adj" fmla="val 6000"/>
+            </a:avLst>
+          </a:prstGeom>
+          <a:solidFill>
+            <a:srgbClr val="FFFFFF"/>
+          </a:solidFill>
+          <a:ln w="12700">
+            <a:solidFill>
+              <a:srgbClr val="E3E8F2"/>
+            </a:solidFill>
+          </a:ln>
+          <a:effectLst/>
+        </p:spPr>
+        <p:style>
+          <a:lnRef idx="1">
+            <a:schemeClr val="accent1"/>
+          </a:lnRef>
+          <a:fillRef idx="3">
+            <a:schemeClr val="accent1"/>
+          </a:fillRef>
+          <a:effectRef idx="2">
+            <a:schemeClr val="accent1"/>
+          </a:effectRef>
+          <a:fontRef idx="minor">
+            <a:schemeClr val="lt1"/>
+          </a:fontRef>
+        </p:style>
+        <p:txBody>
+          <a:bodyPr rtlCol="0" anchor="ctr"/>
+          <a:lstStyle/>
+          <a:p>
+            <a:pPr algn="ctr"/>
+          </a:p>
+        </p:txBody>
+      </p:sp>
+      <p:sp>
+        <p:nvSpPr>
+          <p:cNvPr id="14" name="Rectangle 13"/>
+          <p:cNvSpPr/>
+          <p:nvPr/>
+        </p:nvSpPr>
+        <p:spPr>
+          <a:xfrm>
+            <a:off x="4270248" y="1645920"/>
+            <a:ext cx="3657600" cy="128016"/>
+          </a:xfrm>
+          <a:prstGeom prst="rect">
+            <a:avLst/>
+          </a:prstGeom>
+          <a:solidFill>
+            <a:srgbClr val="F58220"/>
+          </a:solidFill>
+          <a:ln>
+            <a:noFill/>
+          </a:ln>
+          <a:effectLst/>
+        </p:spPr>
+        <p:style>
+          <a:lnRef idx="1">
+            <a:schemeClr val="accent1"/>
+          </a:lnRef>
+          <a:fillRef idx="3">
+            <a:schemeClr val="accent1"/>
+          </a:fillRef>
+          <a:effectRef idx="2">
+            <a:schemeClr val="accent1"/>
+          </a:effectRef>
+          <a:fontRef idx="minor">
+            <a:schemeClr val="lt1"/>
+          </a:fontRef>
+        </p:style>
+        <p:txBody>
+          <a:bodyPr rtlCol="0" anchor="ctr"/>
+          <a:lstStyle/>
+          <a:p>
+            <a:pPr algn="ctr"/>
+          </a:p>
+        </p:txBody>
+      </p:sp>
+      <p:sp>
+        <p:nvSpPr>
+          <p:cNvPr id="15" name="TextBox 14"/>
+          <p:cNvSpPr txBox="1"/>
+          <p:nvPr/>
+        </p:nvSpPr>
+        <p:spPr>
+          <a:xfrm>
+            <a:off x="4544568" y="1965960"/>
+            <a:ext cx="3108960" cy="548640"/>
+          </a:xfrm>
+          <a:prstGeom prst="rect">
+            <a:avLst/>
+          </a:prstGeom>
+          <a:noFill/>
+        </p:spPr>
+        <p:txBody>
+          <a:bodyPr wrap="square" anchor="t" lIns="0" rIns="0" tIns="0" bIns="0">
+            <a:spAutoFit/>
+          </a:bodyPr>
+          <a:lstStyle/>
+          <a:p>
+            <a:pPr algn="l">
+              <a:lnSpc>
+                <a:spcPct val="100000"/>
+              </a:lnSpc>
+              <a:spcAft>
+                <a:spcPts val="600"/>
+              </a:spcAft>
+            </a:pPr>
+            <a:r>
+              <a:rPr sz="1700" b="1" i="0">
+                <a:solidFill>
+                  <a:srgbClr val="0E1F3D"/>
+                </a:solidFill>
+                <a:latin typeface="Arial"/>
+              </a:rPr>
+              <a:t>Gói tích hợp core</a:t>
+            </a:r>
+          </a:p>
+        </p:txBody>
+      </p:sp>
+      <p:sp>
+        <p:nvSpPr>
+          <p:cNvPr id="16" name="TextBox 15"/>
+          <p:cNvSpPr txBox="1"/>
+          <p:nvPr/>
+        </p:nvSpPr>
+        <p:spPr>
+          <a:xfrm>
+            <a:off x="4544568" y="2514600"/>
+            <a:ext cx="3108960" cy="1645920"/>
+          </a:xfrm>
+          <a:prstGeom prst="rect">
+            <a:avLst/>
+          </a:prstGeom>
+          <a:noFill/>
+        </p:spPr>
+        <p:txBody>
+          <a:bodyPr wrap="square" anchor="t" lIns="0" rIns="0" tIns="0" bIns="0">
+            <a:spAutoFit/>
+          </a:bodyPr>
+          <a:lstStyle/>
+          <a:p>
+            <a:pPr algn="l">
+              <a:lnSpc>
+                <a:spcPct val="112000"/>
+              </a:lnSpc>
+              <a:spcAft>
+                <a:spcPts val="600"/>
+              </a:spcAft>
+            </a:pPr>
+            <a:r>
+              <a:rPr sz="1350" b="0" i="0">
+                <a:solidFill>
+                  <a:srgbClr val="51617F"/>
+                </a:solidFill>
+                <a:latin typeface="Arial"/>
+              </a:rPr>
+              <a:t>Phí triển khai một lần: adapter vào core (Intellect/ESB), mapping trường theo nghiệp vụ từng ngân hàng, đào tạo.</a:t>
+            </a:r>
+          </a:p>
+        </p:txBody>
+      </p:sp>
+      <p:sp>
+        <p:nvSpPr>
+          <p:cNvPr id="17" name="Rounded Rectangle 16"/>
+          <p:cNvSpPr/>
+          <p:nvPr/>
+        </p:nvSpPr>
+        <p:spPr>
+          <a:xfrm>
+            <a:off x="8037576" y="1645920"/>
+            <a:ext cx="3657600" cy="2651760"/>
+          </a:xfrm>
+          <a:prstGeom prst="roundRect">
+            <a:avLst>
+              <a:gd name="adj" fmla="val 6000"/>
+            </a:avLst>
+          </a:prstGeom>
+          <a:solidFill>
+            <a:srgbClr val="FFFFFF"/>
+          </a:solidFill>
+          <a:ln w="12700">
+            <a:solidFill>
+              <a:srgbClr val="E3E8F2"/>
+            </a:solidFill>
+          </a:ln>
+          <a:effectLst/>
+        </p:spPr>
+        <p:style>
+          <a:lnRef idx="1">
+            <a:schemeClr val="accent1"/>
+          </a:lnRef>
+          <a:fillRef idx="3">
+            <a:schemeClr val="accent1"/>
+          </a:fillRef>
+          <a:effectRef idx="2">
+            <a:schemeClr val="accent1"/>
+          </a:effectRef>
+          <a:fontRef idx="minor">
+            <a:schemeClr val="lt1"/>
+          </a:fontRef>
+        </p:style>
+        <p:txBody>
+          <a:bodyPr rtlCol="0" anchor="ctr"/>
+          <a:lstStyle/>
+          <a:p>
+            <a:pPr algn="ctr"/>
+          </a:p>
+        </p:txBody>
+      </p:sp>
+      <p:sp>
+        <p:nvSpPr>
+          <p:cNvPr id="18" name="Rectangle 17"/>
+          <p:cNvSpPr/>
+          <p:nvPr/>
+        </p:nvSpPr>
+        <p:spPr>
+          <a:xfrm>
+            <a:off x="8037576" y="1645920"/>
+            <a:ext cx="3657600" cy="128016"/>
+          </a:xfrm>
+          <a:prstGeom prst="rect">
+            <a:avLst/>
+          </a:prstGeom>
+          <a:solidFill>
+            <a:srgbClr val="F58220"/>
+          </a:solidFill>
+          <a:ln>
+            <a:noFill/>
+          </a:ln>
+          <a:effectLst/>
+        </p:spPr>
+        <p:style>
+          <a:lnRef idx="1">
+            <a:schemeClr val="accent1"/>
+          </a:lnRef>
+          <a:fillRef idx="3">
+            <a:schemeClr val="accent1"/>
+          </a:fillRef>
+          <a:effectRef idx="2">
+            <a:schemeClr val="accent1"/>
+          </a:effectRef>
+          <a:fontRef idx="minor">
+            <a:schemeClr val="lt1"/>
+          </a:fontRef>
+        </p:style>
+        <p:txBody>
+          <a:bodyPr rtlCol="0" anchor="ctr"/>
+          <a:lstStyle/>
+          <a:p>
+            <a:pPr algn="ctr"/>
+          </a:p>
+        </p:txBody>
+      </p:sp>
+      <p:sp>
+        <p:nvSpPr>
+          <p:cNvPr id="19" name="TextBox 18"/>
+          <p:cNvSpPr txBox="1"/>
+          <p:nvPr/>
+        </p:nvSpPr>
+        <p:spPr>
+          <a:xfrm>
+            <a:off x="8311896" y="1965960"/>
+            <a:ext cx="3108960" cy="548640"/>
+          </a:xfrm>
+          <a:prstGeom prst="rect">
+            <a:avLst/>
+          </a:prstGeom>
+          <a:noFill/>
+        </p:spPr>
+        <p:txBody>
+          <a:bodyPr wrap="square" anchor="t" lIns="0" rIns="0" tIns="0" bIns="0">
+            <a:spAutoFit/>
+          </a:bodyPr>
+          <a:lstStyle/>
+          <a:p>
+            <a:pPr algn="l">
+              <a:lnSpc>
+                <a:spcPct val="100000"/>
+              </a:lnSpc>
+              <a:spcAft>
+                <a:spcPts val="600"/>
+              </a:spcAft>
+            </a:pPr>
+            <a:r>
+              <a:rPr sz="1700" b="1" i="0">
+                <a:solidFill>
+                  <a:srgbClr val="0E1F3D"/>
+                </a:solidFill>
+                <a:latin typeface="Arial"/>
+              </a:rPr>
+              <a:t>Thuê bao vận hành</a:t>
+            </a:r>
+          </a:p>
+        </p:txBody>
+      </p:sp>
+      <p:sp>
+        <p:nvSpPr>
+          <p:cNvPr id="20" name="TextBox 19"/>
+          <p:cNvSpPr txBox="1"/>
+          <p:nvPr/>
+        </p:nvSpPr>
+        <p:spPr>
+          <a:xfrm>
+            <a:off x="8311896" y="2514600"/>
+            <a:ext cx="3108960" cy="1645920"/>
+          </a:xfrm>
+          <a:prstGeom prst="rect">
+            <a:avLst/>
+          </a:prstGeom>
+          <a:noFill/>
+        </p:spPr>
+        <p:txBody>
+          <a:bodyPr wrap="square" anchor="t" lIns="0" rIns="0" tIns="0" bIns="0">
+            <a:spAutoFit/>
+          </a:bodyPr>
+          <a:lstStyle/>
+          <a:p>
+            <a:pPr algn="l">
+              <a:lnSpc>
+                <a:spcPct val="112000"/>
+              </a:lnSpc>
+              <a:spcAft>
+                <a:spcPts val="600"/>
+              </a:spcAft>
+            </a:pPr>
+            <a:r>
+              <a:rPr sz="1350" b="0" i="0">
+                <a:solidFill>
+                  <a:srgbClr val="51617F"/>
+                </a:solidFill>
+                <a:latin typeface="Arial"/>
+              </a:rPr>
+              <a:t>Theo chi nhánh/tháng: dashboard KPI, audit log, cấu hình trường tùy chỉnh, SLA hỗ trợ.</a:t>
+            </a:r>
+          </a:p>
+        </p:txBody>
+      </p:sp>
+      <p:sp>
+        <p:nvSpPr>
+          <p:cNvPr id="21" name="TextBox 20"/>
+          <p:cNvSpPr txBox="1"/>
+          <p:nvPr/>
+        </p:nvSpPr>
+        <p:spPr>
+          <a:xfrm>
+            <a:off x="502920" y="4617720"/>
+            <a:ext cx="11155680" cy="1463040"/>
+          </a:xfrm>
+          <a:prstGeom prst="rect">
+            <a:avLst/>
+          </a:prstGeom>
+          <a:noFill/>
+        </p:spPr>
+        <p:txBody>
+          <a:bodyPr wrap="square" anchor="t" lIns="0" rIns="0" tIns="0" bIns="0">
+            <a:spAutoFit/>
+          </a:bodyPr>
+          <a:lstStyle/>
+          <a:p>
+            <a:pPr algn="l">
+              <a:lnSpc>
+                <a:spcPct val="125000"/>
+              </a:lnSpc>
+              <a:spcAft>
+                <a:spcPts val="600"/>
+              </a:spcAft>
+            </a:pPr>
+            <a:r>
+              <a:rPr sz="1550" b="1" i="0">
+                <a:solidFill>
+                  <a:srgbClr val="0E1F3D"/>
+                </a:solidFill>
+                <a:latin typeface="Arial"/>
+              </a:rPr>
+              <a:t>Đơn vị kinh tế: </a:t>
+            </a:r>
+            <a:r>
+              <a:rPr sz="1550" b="0" i="0">
+                <a:solidFill>
+                  <a:srgbClr val="51617F"/>
+                </a:solidFill>
+                <a:latin typeface="Arial"/>
+              </a:rPr>
+              <a:t>10.000 bộ/tháng ≈ 5 triệu đồng chi phí AI — đổi lấy hàng nghìn giờ công nghiệp vụ. Biên gộp phần mềm &gt; 90%.</a:t>
+            </a:r>
+          </a:p>
+          <a:p>
+            <a:pPr algn="l">
+              <a:lnSpc>
+                <a:spcPct val="125000"/>
+              </a:lnSpc>
+              <a:spcAft>
+                <a:spcPts val="600"/>
+              </a:spcAft>
+            </a:pPr>
+            <a:r>
+              <a:rPr sz="1550" b="1" i="0">
+                <a:solidFill>
+                  <a:srgbClr val="0E1F3D"/>
+                </a:solidFill>
+                <a:latin typeface="Arial"/>
+              </a:rPr>
+              <a:t>Thị trường: </a:t>
+            </a:r>
+            <a:r>
+              <a:rPr sz="1550" b="0" i="0">
+                <a:solidFill>
+                  <a:srgbClr val="51617F"/>
+                </a:solidFill>
+                <a:latin typeface="Arial"/>
+              </a:rPr>
+              <a:t>bắt đầu từ pilot SHB → nhân rộng khối ngân hàng thương mại Việt Nam; cùng một lõi dùng được cho bảo hiểm, chứng khoán, công ty tài chính.</a:t>
             </a:r>
           </a:p>
         </p:txBody>
@@ -5320,6 +5617,705 @@
             <a:avLst/>
           </a:prstGeom>
           <a:solidFill>
+            <a:srgbClr val="F7F8FB"/>
+          </a:solidFill>
+          <a:ln>
+            <a:noFill/>
+          </a:ln>
+          <a:effectLst/>
+        </p:spPr>
+        <p:style>
+          <a:lnRef idx="1">
+            <a:schemeClr val="accent1"/>
+          </a:lnRef>
+          <a:fillRef idx="3">
+            <a:schemeClr val="accent1"/>
+          </a:fillRef>
+          <a:effectRef idx="2">
+            <a:schemeClr val="accent1"/>
+          </a:effectRef>
+          <a:fontRef idx="minor">
+            <a:schemeClr val="lt1"/>
+          </a:fontRef>
+        </p:style>
+        <p:txBody>
+          <a:bodyPr rtlCol="0" anchor="ctr"/>
+          <a:lstStyle/>
+          <a:p>
+            <a:pPr algn="ctr"/>
+          </a:p>
+        </p:txBody>
+      </p:sp>
+      <p:sp>
+        <p:nvSpPr>
+          <p:cNvPr id="3" name="Rectangle 2"/>
+          <p:cNvSpPr/>
+          <p:nvPr/>
+        </p:nvSpPr>
+        <p:spPr>
+          <a:xfrm>
+            <a:off x="502920" y="475488"/>
+            <a:ext cx="201168" cy="201168"/>
+          </a:xfrm>
+          <a:prstGeom prst="rect">
+            <a:avLst/>
+          </a:prstGeom>
+          <a:solidFill>
+            <a:srgbClr val="F58220"/>
+          </a:solidFill>
+          <a:ln>
+            <a:noFill/>
+          </a:ln>
+          <a:effectLst/>
+        </p:spPr>
+        <p:style>
+          <a:lnRef idx="1">
+            <a:schemeClr val="accent1"/>
+          </a:lnRef>
+          <a:fillRef idx="3">
+            <a:schemeClr val="accent1"/>
+          </a:fillRef>
+          <a:effectRef idx="2">
+            <a:schemeClr val="accent1"/>
+          </a:effectRef>
+          <a:fontRef idx="minor">
+            <a:schemeClr val="lt1"/>
+          </a:fontRef>
+        </p:style>
+        <p:txBody>
+          <a:bodyPr rtlCol="0" anchor="ctr"/>
+          <a:lstStyle/>
+          <a:p>
+            <a:pPr algn="ctr"/>
+          </a:p>
+        </p:txBody>
+      </p:sp>
+      <p:sp>
+        <p:nvSpPr>
+          <p:cNvPr id="4" name="TextBox 3"/>
+          <p:cNvSpPr txBox="1"/>
+          <p:nvPr/>
+        </p:nvSpPr>
+        <p:spPr>
+          <a:xfrm>
+            <a:off x="868680" y="274320"/>
+            <a:ext cx="9601200" cy="274320"/>
+          </a:xfrm>
+          <a:prstGeom prst="rect">
+            <a:avLst/>
+          </a:prstGeom>
+          <a:noFill/>
+        </p:spPr>
+        <p:txBody>
+          <a:bodyPr wrap="square" anchor="t" lIns="0" rIns="0" tIns="0" bIns="0">
+            <a:spAutoFit/>
+          </a:bodyPr>
+          <a:lstStyle/>
+          <a:p>
+            <a:pPr algn="l">
+              <a:lnSpc>
+                <a:spcPct val="100000"/>
+              </a:lnSpc>
+              <a:spcAft>
+                <a:spcPts val="600"/>
+              </a:spcAft>
+            </a:pPr>
+            <a:r>
+              <a:rPr sz="1200" b="1" i="0">
+                <a:solidFill>
+                  <a:srgbClr val="C25605"/>
+                </a:solidFill>
+                <a:latin typeface="Arial"/>
+              </a:rPr>
+              <a:t>PILOT PATHWAY</a:t>
+            </a:r>
+          </a:p>
+        </p:txBody>
+      </p:sp>
+      <p:sp>
+        <p:nvSpPr>
+          <p:cNvPr id="5" name="TextBox 4"/>
+          <p:cNvSpPr txBox="1"/>
+          <p:nvPr/>
+        </p:nvSpPr>
+        <p:spPr>
+          <a:xfrm>
+            <a:off x="868680" y="530352"/>
+            <a:ext cx="10058400" cy="640080"/>
+          </a:xfrm>
+          <a:prstGeom prst="rect">
+            <a:avLst/>
+          </a:prstGeom>
+          <a:noFill/>
+        </p:spPr>
+        <p:txBody>
+          <a:bodyPr wrap="square" anchor="t" lIns="0" rIns="0" tIns="0" bIns="0">
+            <a:spAutoFit/>
+          </a:bodyPr>
+          <a:lstStyle/>
+          <a:p>
+            <a:pPr algn="l">
+              <a:lnSpc>
+                <a:spcPct val="100000"/>
+              </a:lnSpc>
+              <a:spcAft>
+                <a:spcPts val="600"/>
+              </a:spcAft>
+            </a:pPr>
+            <a:r>
+              <a:rPr sz="3000" b="1" i="0">
+                <a:solidFill>
+                  <a:srgbClr val="0E1F3D"/>
+                </a:solidFill>
+                <a:latin typeface="Arial"/>
+              </a:rPr>
+              <a:t>Lộ trình pilot — bật công tắc là chạy</a:t>
+            </a:r>
+          </a:p>
+        </p:txBody>
+      </p:sp>
+      <p:sp>
+        <p:nvSpPr>
+          <p:cNvPr id="6" name="Rectangle 5"/>
+          <p:cNvSpPr/>
+          <p:nvPr/>
+        </p:nvSpPr>
+        <p:spPr>
+          <a:xfrm>
+            <a:off x="502920" y="1207008"/>
+            <a:ext cx="11183112" cy="17780"/>
+          </a:xfrm>
+          <a:prstGeom prst="rect">
+            <a:avLst/>
+          </a:prstGeom>
+          <a:solidFill>
+            <a:srgbClr val="E3E8F2"/>
+          </a:solidFill>
+          <a:ln>
+            <a:noFill/>
+          </a:ln>
+          <a:effectLst/>
+        </p:spPr>
+        <p:style>
+          <a:lnRef idx="1">
+            <a:schemeClr val="accent1"/>
+          </a:lnRef>
+          <a:fillRef idx="3">
+            <a:schemeClr val="accent1"/>
+          </a:fillRef>
+          <a:effectRef idx="2">
+            <a:schemeClr val="accent1"/>
+          </a:effectRef>
+          <a:fontRef idx="minor">
+            <a:schemeClr val="lt1"/>
+          </a:fontRef>
+        </p:style>
+        <p:txBody>
+          <a:bodyPr rtlCol="0" anchor="ctr"/>
+          <a:lstStyle/>
+          <a:p>
+            <a:pPr algn="ctr"/>
+          </a:p>
+        </p:txBody>
+      </p:sp>
+      <p:sp>
+        <p:nvSpPr>
+          <p:cNvPr id="7" name="TextBox 6"/>
+          <p:cNvSpPr txBox="1"/>
+          <p:nvPr/>
+        </p:nvSpPr>
+        <p:spPr>
+          <a:xfrm>
+            <a:off x="502920" y="6455664"/>
+            <a:ext cx="7315200" cy="274320"/>
+          </a:xfrm>
+          <a:prstGeom prst="rect">
+            <a:avLst/>
+          </a:prstGeom>
+          <a:noFill/>
+        </p:spPr>
+        <p:txBody>
+          <a:bodyPr wrap="square" anchor="t" lIns="0" rIns="0" tIns="0" bIns="0">
+            <a:spAutoFit/>
+          </a:bodyPr>
+          <a:lstStyle/>
+          <a:p>
+            <a:pPr algn="l">
+              <a:lnSpc>
+                <a:spcPct val="100000"/>
+              </a:lnSpc>
+              <a:spcAft>
+                <a:spcPts val="600"/>
+              </a:spcAft>
+            </a:pPr>
+            <a:r>
+              <a:rPr sz="1000" b="0" i="0">
+                <a:solidFill>
+                  <a:srgbClr val="51617F"/>
+                </a:solidFill>
+                <a:latin typeface="Arial"/>
+              </a:rPr>
+              <a:t>DocFlow · Team OCanbubu · Đề SHB #195 — Intelligent Document Processing</a:t>
+            </a:r>
+          </a:p>
+        </p:txBody>
+      </p:sp>
+      <p:sp>
+        <p:nvSpPr>
+          <p:cNvPr id="8" name="TextBox 7"/>
+          <p:cNvSpPr txBox="1"/>
+          <p:nvPr/>
+        </p:nvSpPr>
+        <p:spPr>
+          <a:xfrm>
+            <a:off x="11155680" y="6455664"/>
+            <a:ext cx="548640" cy="274320"/>
+          </a:xfrm>
+          <a:prstGeom prst="rect">
+            <a:avLst/>
+          </a:prstGeom>
+          <a:noFill/>
+        </p:spPr>
+        <p:txBody>
+          <a:bodyPr wrap="square" anchor="t" lIns="0" rIns="0" tIns="0" bIns="0">
+            <a:spAutoFit/>
+          </a:bodyPr>
+          <a:lstStyle/>
+          <a:p>
+            <a:pPr algn="r">
+              <a:lnSpc>
+                <a:spcPct val="100000"/>
+              </a:lnSpc>
+              <a:spcAft>
+                <a:spcPts val="600"/>
+              </a:spcAft>
+            </a:pPr>
+            <a:r>
+              <a:rPr sz="1000" b="0" i="0">
+                <a:solidFill>
+                  <a:srgbClr val="51617F"/>
+                </a:solidFill>
+                <a:latin typeface="Arial"/>
+              </a:rPr>
+              <a:t>11</a:t>
+            </a:r>
+          </a:p>
+        </p:txBody>
+      </p:sp>
+      <p:sp>
+        <p:nvSpPr>
+          <p:cNvPr id="9" name="Rounded Rectangle 8"/>
+          <p:cNvSpPr/>
+          <p:nvPr/>
+        </p:nvSpPr>
+        <p:spPr>
+          <a:xfrm>
+            <a:off x="502920" y="1737360"/>
+            <a:ext cx="1554480" cy="914400"/>
+          </a:xfrm>
+          <a:prstGeom prst="roundRect">
+            <a:avLst>
+              <a:gd name="adj" fmla="val 14000"/>
+            </a:avLst>
+          </a:prstGeom>
+          <a:solidFill>
+            <a:srgbClr val="0E1F3D"/>
+          </a:solidFill>
+          <a:ln>
+            <a:noFill/>
+          </a:ln>
+          <a:effectLst/>
+        </p:spPr>
+        <p:style>
+          <a:lnRef idx="1">
+            <a:schemeClr val="accent1"/>
+          </a:lnRef>
+          <a:fillRef idx="3">
+            <a:schemeClr val="accent1"/>
+          </a:fillRef>
+          <a:effectRef idx="2">
+            <a:schemeClr val="accent1"/>
+          </a:effectRef>
+          <a:fontRef idx="minor">
+            <a:schemeClr val="lt1"/>
+          </a:fontRef>
+        </p:style>
+        <p:txBody>
+          <a:bodyPr rtlCol="0" anchor="ctr"/>
+          <a:lstStyle/>
+          <a:p>
+            <a:pPr algn="ctr"/>
+            <a:r>
+              <a:rPr sz="1700" b="1">
+                <a:solidFill>
+                  <a:srgbClr val="FFFFFF"/>
+                </a:solidFill>
+                <a:latin typeface="Arial"/>
+              </a:rPr>
+              <a:t>2 tuần</a:t>
+            </a:r>
+          </a:p>
+        </p:txBody>
+      </p:sp>
+      <p:sp>
+        <p:nvSpPr>
+          <p:cNvPr id="10" name="TextBox 9"/>
+          <p:cNvSpPr txBox="1"/>
+          <p:nvPr/>
+        </p:nvSpPr>
+        <p:spPr>
+          <a:xfrm>
+            <a:off x="2331720" y="1847088"/>
+            <a:ext cx="9326880" cy="822960"/>
+          </a:xfrm>
+          <a:prstGeom prst="rect">
+            <a:avLst/>
+          </a:prstGeom>
+          <a:noFill/>
+        </p:spPr>
+        <p:txBody>
+          <a:bodyPr wrap="square" anchor="t" lIns="0" rIns="0" tIns="0" bIns="0">
+            <a:spAutoFit/>
+          </a:bodyPr>
+          <a:lstStyle/>
+          <a:p>
+            <a:pPr algn="l">
+              <a:lnSpc>
+                <a:spcPct val="110000"/>
+              </a:lnSpc>
+              <a:spcAft>
+                <a:spcPts val="600"/>
+              </a:spcAft>
+            </a:pPr>
+            <a:r>
+              <a:rPr sz="1550" b="0" i="0">
+                <a:solidFill>
+                  <a:srgbClr val="0E1F3D"/>
+                </a:solidFill>
+                <a:latin typeface="Arial"/>
+              </a:rPr>
+              <a:t>Sandbox trên hồ sơ ẩn danh SHB — đo accuracy trên dữ liệu thật của ngân hàng</a:t>
+            </a:r>
+          </a:p>
+        </p:txBody>
+      </p:sp>
+      <p:sp>
+        <p:nvSpPr>
+          <p:cNvPr id="11" name="Rounded Rectangle 10"/>
+          <p:cNvSpPr/>
+          <p:nvPr/>
+        </p:nvSpPr>
+        <p:spPr>
+          <a:xfrm>
+            <a:off x="502920" y="2880360"/>
+            <a:ext cx="1554480" cy="914400"/>
+          </a:xfrm>
+          <a:prstGeom prst="roundRect">
+            <a:avLst>
+              <a:gd name="adj" fmla="val 14000"/>
+            </a:avLst>
+          </a:prstGeom>
+          <a:solidFill>
+            <a:srgbClr val="0E1F3D"/>
+          </a:solidFill>
+          <a:ln>
+            <a:noFill/>
+          </a:ln>
+          <a:effectLst/>
+        </p:spPr>
+        <p:style>
+          <a:lnRef idx="1">
+            <a:schemeClr val="accent1"/>
+          </a:lnRef>
+          <a:fillRef idx="3">
+            <a:schemeClr val="accent1"/>
+          </a:fillRef>
+          <a:effectRef idx="2">
+            <a:schemeClr val="accent1"/>
+          </a:effectRef>
+          <a:fontRef idx="minor">
+            <a:schemeClr val="lt1"/>
+          </a:fontRef>
+        </p:style>
+        <p:txBody>
+          <a:bodyPr rtlCol="0" anchor="ctr"/>
+          <a:lstStyle/>
+          <a:p>
+            <a:pPr algn="ctr"/>
+            <a:r>
+              <a:rPr sz="1700" b="1">
+                <a:solidFill>
+                  <a:srgbClr val="FFFFFF"/>
+                </a:solidFill>
+                <a:latin typeface="Arial"/>
+              </a:rPr>
+              <a:t>3 tháng</a:t>
+            </a:r>
+          </a:p>
+        </p:txBody>
+      </p:sp>
+      <p:sp>
+        <p:nvSpPr>
+          <p:cNvPr id="12" name="TextBox 11"/>
+          <p:cNvSpPr txBox="1"/>
+          <p:nvPr/>
+        </p:nvSpPr>
+        <p:spPr>
+          <a:xfrm>
+            <a:off x="2331720" y="2990088"/>
+            <a:ext cx="9326880" cy="822960"/>
+          </a:xfrm>
+          <a:prstGeom prst="rect">
+            <a:avLst/>
+          </a:prstGeom>
+          <a:noFill/>
+        </p:spPr>
+        <p:txBody>
+          <a:bodyPr wrap="square" anchor="t" lIns="0" rIns="0" tIns="0" bIns="0">
+            <a:spAutoFit/>
+          </a:bodyPr>
+          <a:lstStyle/>
+          <a:p>
+            <a:pPr algn="l">
+              <a:lnSpc>
+                <a:spcPct val="110000"/>
+              </a:lnSpc>
+              <a:spcAft>
+                <a:spcPts val="600"/>
+              </a:spcAft>
+            </a:pPr>
+            <a:r>
+              <a:rPr sz="1550" b="0" i="0">
+                <a:solidFill>
+                  <a:srgbClr val="0E1F3D"/>
+                </a:solidFill>
+                <a:latin typeface="Arial"/>
+              </a:rPr>
+              <a:t>Pilot một chi nhánh, luồng vay cá nhân — KPI: 70% trường tự động, đo thời gian tiết kiệm</a:t>
+            </a:r>
+          </a:p>
+        </p:txBody>
+      </p:sp>
+      <p:sp>
+        <p:nvSpPr>
+          <p:cNvPr id="13" name="Rounded Rectangle 12"/>
+          <p:cNvSpPr/>
+          <p:nvPr/>
+        </p:nvSpPr>
+        <p:spPr>
+          <a:xfrm>
+            <a:off x="502920" y="4023360"/>
+            <a:ext cx="1554480" cy="914400"/>
+          </a:xfrm>
+          <a:prstGeom prst="roundRect">
+            <a:avLst>
+              <a:gd name="adj" fmla="val 14000"/>
+            </a:avLst>
+          </a:prstGeom>
+          <a:solidFill>
+            <a:srgbClr val="0E1F3D"/>
+          </a:solidFill>
+          <a:ln>
+            <a:noFill/>
+          </a:ln>
+          <a:effectLst/>
+        </p:spPr>
+        <p:style>
+          <a:lnRef idx="1">
+            <a:schemeClr val="accent1"/>
+          </a:lnRef>
+          <a:fillRef idx="3">
+            <a:schemeClr val="accent1"/>
+          </a:fillRef>
+          <a:effectRef idx="2">
+            <a:schemeClr val="accent1"/>
+          </a:effectRef>
+          <a:fontRef idx="minor">
+            <a:schemeClr val="lt1"/>
+          </a:fontRef>
+        </p:style>
+        <p:txBody>
+          <a:bodyPr rtlCol="0" anchor="ctr"/>
+          <a:lstStyle/>
+          <a:p>
+            <a:pPr algn="ctr"/>
+            <a:r>
+              <a:rPr sz="1700" b="1">
+                <a:solidFill>
+                  <a:srgbClr val="FFFFFF"/>
+                </a:solidFill>
+                <a:latin typeface="Arial"/>
+              </a:rPr>
+              <a:t>6 tháng</a:t>
+            </a:r>
+          </a:p>
+        </p:txBody>
+      </p:sp>
+      <p:sp>
+        <p:nvSpPr>
+          <p:cNvPr id="14" name="TextBox 13"/>
+          <p:cNvSpPr txBox="1"/>
+          <p:nvPr/>
+        </p:nvSpPr>
+        <p:spPr>
+          <a:xfrm>
+            <a:off x="2331720" y="4133088"/>
+            <a:ext cx="9326880" cy="822960"/>
+          </a:xfrm>
+          <a:prstGeom prst="rect">
+            <a:avLst/>
+          </a:prstGeom>
+          <a:noFill/>
+        </p:spPr>
+        <p:txBody>
+          <a:bodyPr wrap="square" anchor="t" lIns="0" rIns="0" tIns="0" bIns="0">
+            <a:spAutoFit/>
+          </a:bodyPr>
+          <a:lstStyle/>
+          <a:p>
+            <a:pPr algn="l">
+              <a:lnSpc>
+                <a:spcPct val="110000"/>
+              </a:lnSpc>
+              <a:spcAft>
+                <a:spcPts val="600"/>
+              </a:spcAft>
+            </a:pPr>
+            <a:r>
+              <a:rPr sz="1550" b="0" i="0">
+                <a:solidFill>
+                  <a:srgbClr val="0E1F3D"/>
+                </a:solidFill>
+                <a:latin typeface="Arial"/>
+              </a:rPr>
+              <a:t>Distill sang extractor PyTorch chuyên biệt chạy on-prem — nhãn lấy từ chính review queue, dữ liệu không rời ngân hàng, chi phí biên tiệm cận 0</a:t>
+            </a:r>
+          </a:p>
+        </p:txBody>
+      </p:sp>
+      <p:sp>
+        <p:nvSpPr>
+          <p:cNvPr id="15" name="Rounded Rectangle 14"/>
+          <p:cNvSpPr/>
+          <p:nvPr/>
+        </p:nvSpPr>
+        <p:spPr>
+          <a:xfrm>
+            <a:off x="502920" y="5212080"/>
+            <a:ext cx="11201400" cy="1051560"/>
+          </a:xfrm>
+          <a:prstGeom prst="roundRect">
+            <a:avLst>
+              <a:gd name="adj" fmla="val 10000"/>
+            </a:avLst>
+          </a:prstGeom>
+          <a:solidFill>
+            <a:srgbClr val="FFF7E6"/>
+          </a:solidFill>
+          <a:ln w="15240">
+            <a:solidFill>
+              <a:srgbClr val="F58220"/>
+            </a:solidFill>
+          </a:ln>
+          <a:effectLst/>
+        </p:spPr>
+        <p:style>
+          <a:lnRef idx="1">
+            <a:schemeClr val="accent1"/>
+          </a:lnRef>
+          <a:fillRef idx="3">
+            <a:schemeClr val="accent1"/>
+          </a:fillRef>
+          <a:effectRef idx="2">
+            <a:schemeClr val="accent1"/>
+          </a:effectRef>
+          <a:fontRef idx="minor">
+            <a:schemeClr val="lt1"/>
+          </a:fontRef>
+        </p:style>
+        <p:txBody>
+          <a:bodyPr rtlCol="0" anchor="ctr"/>
+          <a:lstStyle/>
+          <a:p>
+            <a:pPr algn="ctr"/>
+          </a:p>
+        </p:txBody>
+      </p:sp>
+      <p:sp>
+        <p:nvSpPr>
+          <p:cNvPr id="16" name="TextBox 15"/>
+          <p:cNvSpPr txBox="1"/>
+          <p:nvPr/>
+        </p:nvSpPr>
+        <p:spPr>
+          <a:xfrm>
+            <a:off x="868680" y="5431536"/>
+            <a:ext cx="10515600" cy="731520"/>
+          </a:xfrm>
+          <a:prstGeom prst="rect">
+            <a:avLst/>
+          </a:prstGeom>
+          <a:noFill/>
+        </p:spPr>
+        <p:txBody>
+          <a:bodyPr wrap="square" anchor="t" lIns="0" rIns="0" tIns="0" bIns="0">
+            <a:spAutoFit/>
+          </a:bodyPr>
+          <a:lstStyle/>
+          <a:p>
+            <a:pPr algn="ctr">
+              <a:lnSpc>
+                <a:spcPct val="100000"/>
+              </a:lnSpc>
+              <a:spcAft>
+                <a:spcPts val="600"/>
+              </a:spcAft>
+            </a:pPr>
+            <a:r>
+              <a:rPr sz="1900" b="1" i="0">
+                <a:solidFill>
+                  <a:srgbClr val="C25605"/>
+                </a:solidFill>
+                <a:latin typeface="Arial"/>
+              </a:rPr>
+              <a:t>“DocFlow không phải demo hackathon — nó là sản phẩm SHB có thể bật công tắc.”</a:t>
+            </a:r>
+          </a:p>
+        </p:txBody>
+      </p:sp>
+    </p:spTree>
+  </p:cSld>
+  <p:clrMapOvr>
+    <a:masterClrMapping/>
+  </p:clrMapOvr>
+</p:sld>
+</file>
+
+<file path=ppt/slides/slide12.xml><?xml version="1.0" encoding="utf-8"?>
+<p:sld xmlns:a="http://schemas.openxmlformats.org/drawingml/2006/main" xmlns:p="http://schemas.openxmlformats.org/presentationml/2006/main" xmlns:r="http://schemas.openxmlformats.org/officeDocument/2006/relationships">
+  <p:cSld>
+    <p:spTree>
+      <p:nvGrpSpPr>
+        <p:cNvPr id="1" name=""/>
+        <p:cNvGrpSpPr/>
+        <p:nvPr/>
+      </p:nvGrpSpPr>
+      <p:grpSpPr/>
+      <p:sp>
+        <p:nvSpPr>
+          <p:cNvPr id="2" name="Rectangle 1"/>
+          <p:cNvSpPr/>
+          <p:nvPr/>
+        </p:nvSpPr>
+        <p:spPr>
+          <a:xfrm>
+            <a:off x="0" y="0"/>
+            <a:ext cx="12191695" cy="6858000"/>
+          </a:xfrm>
+          <a:prstGeom prst="rect">
+            <a:avLst/>
+          </a:prstGeom>
+          <a:solidFill>
             <a:srgbClr val="0E1F3D"/>
           </a:solidFill>
           <a:ln>
@@ -11638,7 +12634,7 @@
                 </a:solidFill>
                 <a:latin typeface="Arial"/>
               </a:rPr>
-              <a:t>BUSINESS MODEL</a:t>
+              <a:t>CHIẾN LƯỢC CHI PHÍ &amp; CHỦ QUYỀN DỮ LIỆU</a:t>
             </a:r>
           </a:p>
         </p:txBody>
@@ -11680,7 +12676,7 @@
                 </a:solidFill>
                 <a:latin typeface="Arial"/>
               </a:rPr>
-              <a:t>Mô hình kinh doanh</a:t>
+              <a:t>Dùng LLM để bootstrap PyTorch</a:t>
             </a:r>
           </a:p>
         </p:txBody>
@@ -11822,11 +12818,11 @@
         <p:spPr>
           <a:xfrm>
             <a:off x="502920" y="1645920"/>
-            <a:ext cx="3657600" cy="2651760"/>
+            <a:ext cx="3246120" cy="1051560"/>
           </a:xfrm>
           <a:prstGeom prst="roundRect">
             <a:avLst>
-              <a:gd name="adj" fmla="val 6000"/>
+              <a:gd name="adj" fmla="val 10000"/>
             </a:avLst>
           </a:prstGeom>
           <a:solidFill>
@@ -11870,13 +12866,13 @@
         <p:spPr>
           <a:xfrm>
             <a:off x="502920" y="1645920"/>
-            <a:ext cx="3657600" cy="128016"/>
+            <a:ext cx="82296" cy="1051560"/>
           </a:xfrm>
           <a:prstGeom prst="rect">
             <a:avLst/>
           </a:prstGeom>
           <a:solidFill>
-            <a:srgbClr val="C25605"/>
+            <a:srgbClr val="F58220"/>
           </a:solidFill>
           <a:ln>
             <a:noFill/>
@@ -11913,8 +12909,8 @@
         </p:nvSpPr>
         <p:spPr>
           <a:xfrm>
-            <a:off x="777240" y="1965960"/>
-            <a:ext cx="3108960" cy="548640"/>
+            <a:off x="758952" y="1755648"/>
+            <a:ext cx="2880360" cy="365760"/>
           </a:xfrm>
           <a:prstGeom prst="rect">
             <a:avLst/>
@@ -11936,13 +12932,13 @@
               </a:spcAft>
             </a:pPr>
             <a:r>
-              <a:rPr sz="1700" b="1" i="0">
+              <a:rPr sz="1450" b="1" i="0">
                 <a:solidFill>
                   <a:srgbClr val="0E1F3D"/>
                 </a:solidFill>
                 <a:latin typeface="Arial"/>
               </a:rPr>
-              <a:t>Phí theo bộ hồ sơ</a:t>
+              <a:t>1 · Gemini đọc hồ sơ hôm nay</a:t>
             </a:r>
           </a:p>
         </p:txBody>
@@ -11955,8 +12951,8 @@
         </p:nvSpPr>
         <p:spPr>
           <a:xfrm>
-            <a:off x="777240" y="2514600"/>
-            <a:ext cx="3108960" cy="1645920"/>
+            <a:off x="758952" y="2121408"/>
+            <a:ext cx="2880360" cy="548640"/>
           </a:xfrm>
           <a:prstGeom prst="rect">
             <a:avLst/>
@@ -11971,20 +12967,20 @@
           <a:p>
             <a:pPr algn="l">
               <a:lnSpc>
-                <a:spcPct val="112000"/>
+                <a:spcPct val="105000"/>
               </a:lnSpc>
               <a:spcAft>
                 <a:spcPts val="600"/>
               </a:spcAft>
             </a:pPr>
             <a:r>
-              <a:rPr sz="1350" b="0" i="0">
+              <a:rPr sz="1150" b="0" i="0">
                 <a:solidFill>
                   <a:srgbClr val="51617F"/>
                 </a:solidFill>
                 <a:latin typeface="Arial"/>
               </a:rPr>
-              <a:t>Thu theo lượt xử lý (SaaS). Chi phí AI &lt; 500đ/bộ — giá bán vài nghìn đồng vẫn rẻ hơn nhiều lần chi phí giờ công nhập tay.</a:t>
+              <a:t>trích xuất mọi loại chứng từ — chi phí &lt; 500đ/bộ</a:t>
             </a:r>
           </a:p>
         </p:txBody>
@@ -11997,12 +12993,12 @@
         </p:nvSpPr>
         <p:spPr>
           <a:xfrm>
-            <a:off x="4270248" y="1645920"/>
-            <a:ext cx="3657600" cy="2651760"/>
+            <a:off x="4343400" y="1645920"/>
+            <a:ext cx="3246120" cy="1051560"/>
           </a:xfrm>
           <a:prstGeom prst="roundRect">
             <a:avLst>
-              <a:gd name="adj" fmla="val 6000"/>
+              <a:gd name="adj" fmla="val 10000"/>
             </a:avLst>
           </a:prstGeom>
           <a:solidFill>
@@ -12045,8 +13041,8 @@
         </p:nvSpPr>
         <p:spPr>
           <a:xfrm>
-            <a:off x="4270248" y="1645920"/>
-            <a:ext cx="3657600" cy="128016"/>
+            <a:off x="4343400" y="1645920"/>
+            <a:ext cx="82296" cy="1051560"/>
           </a:xfrm>
           <a:prstGeom prst="rect">
             <a:avLst/>
@@ -12089,8 +13085,8 @@
         </p:nvSpPr>
         <p:spPr>
           <a:xfrm>
-            <a:off x="4544568" y="1965960"/>
-            <a:ext cx="3108960" cy="548640"/>
+            <a:off x="4599432" y="1755648"/>
+            <a:ext cx="2880360" cy="365760"/>
           </a:xfrm>
           <a:prstGeom prst="rect">
             <a:avLst/>
@@ -12112,13 +13108,13 @@
               </a:spcAft>
             </a:pPr>
             <a:r>
-              <a:rPr sz="1700" b="1" i="0">
+              <a:rPr sz="1450" b="1" i="0">
                 <a:solidFill>
                   <a:srgbClr val="0E1F3D"/>
                 </a:solidFill>
                 <a:latin typeface="Arial"/>
               </a:rPr>
-              <a:t>Gói tích hợp core</a:t>
+              <a:t>2 · Người phê duyệt</a:t>
             </a:r>
           </a:p>
         </p:txBody>
@@ -12131,8 +13127,8 @@
         </p:nvSpPr>
         <p:spPr>
           <a:xfrm>
-            <a:off x="4544568" y="2514600"/>
-            <a:ext cx="3108960" cy="1645920"/>
+            <a:off x="4599432" y="2121408"/>
+            <a:ext cx="2880360" cy="548640"/>
           </a:xfrm>
           <a:prstGeom prst="rect">
             <a:avLst/>
@@ -12147,20 +13143,20 @@
           <a:p>
             <a:pPr algn="l">
               <a:lnSpc>
-                <a:spcPct val="112000"/>
+                <a:spcPct val="105000"/>
               </a:lnSpc>
               <a:spcAft>
                 <a:spcPts val="600"/>
               </a:spcAft>
             </a:pPr>
             <a:r>
-              <a:rPr sz="1350" b="0" i="0">
+              <a:rPr sz="1150" b="0" i="0">
                 <a:solidFill>
                   <a:srgbClr val="51617F"/>
                 </a:solidFill>
                 <a:latin typeface="Arial"/>
               </a:rPr>
-              <a:t>Phí triển khai một lần: adapter vào core (Intellect/ESB), mapping trường theo nghiệp vụ từng ngân hàng, đào tạo.</a:t>
+              <a:t>mỗi trường được duyệt/sửa = 1 nhãn chuẩn kèm bbox</a:t>
             </a:r>
           </a:p>
         </p:txBody>
@@ -12173,12 +13169,12 @@
         </p:nvSpPr>
         <p:spPr>
           <a:xfrm>
-            <a:off x="8037576" y="1645920"/>
-            <a:ext cx="3657600" cy="2651760"/>
+            <a:off x="4343400" y="3611880"/>
+            <a:ext cx="3246120" cy="1051560"/>
           </a:xfrm>
           <a:prstGeom prst="roundRect">
             <a:avLst>
-              <a:gd name="adj" fmla="val 6000"/>
+              <a:gd name="adj" fmla="val 10000"/>
             </a:avLst>
           </a:prstGeom>
           <a:solidFill>
@@ -12221,8 +13217,8 @@
         </p:nvSpPr>
         <p:spPr>
           <a:xfrm>
-            <a:off x="8037576" y="1645920"/>
-            <a:ext cx="3657600" cy="128016"/>
+            <a:off x="4343400" y="3611880"/>
+            <a:ext cx="82296" cy="1051560"/>
           </a:xfrm>
           <a:prstGeom prst="rect">
             <a:avLst/>
@@ -12265,8 +13261,8 @@
         </p:nvSpPr>
         <p:spPr>
           <a:xfrm>
-            <a:off x="8311896" y="1965960"/>
-            <a:ext cx="3108960" cy="548640"/>
+            <a:off x="4599432" y="3721608"/>
+            <a:ext cx="2880360" cy="365760"/>
           </a:xfrm>
           <a:prstGeom prst="rect">
             <a:avLst/>
@@ -12288,13 +13284,13 @@
               </a:spcAft>
             </a:pPr>
             <a:r>
-              <a:rPr sz="1700" b="1" i="0">
+              <a:rPr sz="1450" b="1" i="0">
                 <a:solidFill>
                   <a:srgbClr val="0E1F3D"/>
                 </a:solidFill>
                 <a:latin typeface="Arial"/>
               </a:rPr>
-              <a:t>Thuê bao vận hành</a:t>
+              <a:t>3 · Dataset tự sinh từ vận hành</a:t>
             </a:r>
           </a:p>
         </p:txBody>
@@ -12307,8 +13303,8 @@
         </p:nvSpPr>
         <p:spPr>
           <a:xfrm>
-            <a:off x="8311896" y="2514600"/>
-            <a:ext cx="3108960" cy="1645920"/>
+            <a:off x="4599432" y="4087368"/>
+            <a:ext cx="2880360" cy="548640"/>
           </a:xfrm>
           <a:prstGeom prst="rect">
             <a:avLst/>
@@ -12323,34 +13319,126 @@
           <a:p>
             <a:pPr algn="l">
               <a:lnSpc>
-                <a:spcPct val="112000"/>
+                <a:spcPct val="105000"/>
               </a:lnSpc>
               <a:spcAft>
                 <a:spcPts val="600"/>
               </a:spcAft>
             </a:pPr>
             <a:r>
-              <a:rPr sz="1350" b="0" i="0">
+              <a:rPr sz="1150" b="0" i="0">
                 <a:solidFill>
                   <a:srgbClr val="51617F"/>
                 </a:solidFill>
                 <a:latin typeface="Arial"/>
               </a:rPr>
-              <a:t>Theo chi nhánh/tháng: dashboard KPI, audit log, cấu hình trường tùy chỉnh, SLA hỗ trợ.</a:t>
-            </a:r>
-          </a:p>
-        </p:txBody>
-      </p:sp>
-      <p:sp>
-        <p:nvSpPr>
-          <p:cNvPr id="21" name="TextBox 20"/>
+              <a:t>~nửa triệu nhãn có người kiểm chứng mỗi tháng</a:t>
+            </a:r>
+          </a:p>
+        </p:txBody>
+      </p:sp>
+      <p:sp>
+        <p:nvSpPr>
+          <p:cNvPr id="21" name="Rounded Rectangle 20"/>
+          <p:cNvSpPr/>
+          <p:nvPr/>
+        </p:nvSpPr>
+        <p:spPr>
+          <a:xfrm>
+            <a:off x="502920" y="3611880"/>
+            <a:ext cx="3246120" cy="1051560"/>
+          </a:xfrm>
+          <a:prstGeom prst="roundRect">
+            <a:avLst>
+              <a:gd name="adj" fmla="val 10000"/>
+            </a:avLst>
+          </a:prstGeom>
+          <a:solidFill>
+            <a:srgbClr val="FFF7E6"/>
+          </a:solidFill>
+          <a:ln w="12700">
+            <a:solidFill>
+              <a:srgbClr val="E3E8F2"/>
+            </a:solidFill>
+          </a:ln>
+          <a:effectLst/>
+        </p:spPr>
+        <p:style>
+          <a:lnRef idx="1">
+            <a:schemeClr val="accent1"/>
+          </a:lnRef>
+          <a:fillRef idx="3">
+            <a:schemeClr val="accent1"/>
+          </a:fillRef>
+          <a:effectRef idx="2">
+            <a:schemeClr val="accent1"/>
+          </a:effectRef>
+          <a:fontRef idx="minor">
+            <a:schemeClr val="lt1"/>
+          </a:fontRef>
+        </p:style>
+        <p:txBody>
+          <a:bodyPr rtlCol="0" anchor="ctr"/>
+          <a:lstStyle/>
+          <a:p>
+            <a:pPr algn="ctr"/>
+          </a:p>
+        </p:txBody>
+      </p:sp>
+      <p:sp>
+        <p:nvSpPr>
+          <p:cNvPr id="22" name="Rectangle 21"/>
+          <p:cNvSpPr/>
+          <p:nvPr/>
+        </p:nvSpPr>
+        <p:spPr>
+          <a:xfrm>
+            <a:off x="502920" y="3611880"/>
+            <a:ext cx="82296" cy="1051560"/>
+          </a:xfrm>
+          <a:prstGeom prst="rect">
+            <a:avLst/>
+          </a:prstGeom>
+          <a:solidFill>
+            <a:srgbClr val="C25605"/>
+          </a:solidFill>
+          <a:ln>
+            <a:noFill/>
+          </a:ln>
+          <a:effectLst/>
+        </p:spPr>
+        <p:style>
+          <a:lnRef idx="1">
+            <a:schemeClr val="accent1"/>
+          </a:lnRef>
+          <a:fillRef idx="3">
+            <a:schemeClr val="accent1"/>
+          </a:fillRef>
+          <a:effectRef idx="2">
+            <a:schemeClr val="accent1"/>
+          </a:effectRef>
+          <a:fontRef idx="minor">
+            <a:schemeClr val="lt1"/>
+          </a:fontRef>
+        </p:style>
+        <p:txBody>
+          <a:bodyPr rtlCol="0" anchor="ctr"/>
+          <a:lstStyle/>
+          <a:p>
+            <a:pPr algn="ctr"/>
+          </a:p>
+        </p:txBody>
+      </p:sp>
+      <p:sp>
+        <p:nvSpPr>
+          <p:cNvPr id="23" name="TextBox 22"/>
           <p:cNvSpPr txBox="1"/>
           <p:nvPr/>
         </p:nvSpPr>
         <p:spPr>
           <a:xfrm>
-            <a:off x="502920" y="4617720"/>
-            <a:ext cx="11155680" cy="1463040"/>
+            <a:off x="758952" y="3721608"/>
+            <a:ext cx="2880360" cy="365760"/>
           </a:xfrm>
           <a:prstGeom prst="rect">
             <a:avLst/>
@@ -12365,57 +13453,760 @@
           <a:p>
             <a:pPr algn="l">
               <a:lnSpc>
-                <a:spcPct val="125000"/>
+                <a:spcPct val="100000"/>
               </a:lnSpc>
               <a:spcAft>
                 <a:spcPts val="600"/>
               </a:spcAft>
             </a:pPr>
             <a:r>
-              <a:rPr sz="1550" b="1" i="0">
+              <a:rPr sz="1450" b="1" i="0">
                 <a:solidFill>
                   <a:srgbClr val="0E1F3D"/>
                 </a:solidFill>
                 <a:latin typeface="Arial"/>
               </a:rPr>
-              <a:t>Đơn vị kinh tế: </a:t>
-            </a:r>
-            <a:r>
-              <a:rPr sz="1550" b="0" i="0">
-                <a:solidFill>
-                  <a:srgbClr val="51617F"/>
-                </a:solidFill>
-                <a:latin typeface="Arial"/>
-              </a:rPr>
-              <a:t>10.000 bộ/tháng ≈ 5 triệu đồng chi phí AI — đổi lấy hàng nghìn giờ công nghiệp vụ. Biên gộp phần mềm &gt; 90%.</a:t>
-            </a:r>
-          </a:p>
+              <a:t>4 · Distill sang PyTorch on-prem</a:t>
+            </a:r>
+          </a:p>
+        </p:txBody>
+      </p:sp>
+      <p:sp>
+        <p:nvSpPr>
+          <p:cNvPr id="24" name="TextBox 23"/>
+          <p:cNvSpPr txBox="1"/>
+          <p:nvPr/>
+        </p:nvSpPr>
+        <p:spPr>
+          <a:xfrm>
+            <a:off x="758952" y="4087368"/>
+            <a:ext cx="2880360" cy="548640"/>
+          </a:xfrm>
+          <a:prstGeom prst="rect">
+            <a:avLst/>
+          </a:prstGeom>
+          <a:noFill/>
+        </p:spPr>
+        <p:txBody>
+          <a:bodyPr wrap="square" anchor="t" lIns="0" rIns="0" tIns="0" bIns="0">
+            <a:spAutoFit/>
+          </a:bodyPr>
+          <a:lstStyle/>
           <a:p>
             <a:pPr algn="l">
               <a:lnSpc>
-                <a:spcPct val="125000"/>
+                <a:spcPct val="105000"/>
               </a:lnSpc>
               <a:spcAft>
                 <a:spcPts val="600"/>
               </a:spcAft>
             </a:pPr>
             <a:r>
-              <a:rPr sz="1550" b="1" i="0">
-                <a:solidFill>
-                  <a:srgbClr val="0E1F3D"/>
-                </a:solidFill>
-                <a:latin typeface="Arial"/>
-              </a:rPr>
-              <a:t>Thị trường: </a:t>
-            </a:r>
-            <a:r>
-              <a:rPr sz="1550" b="0" i="0">
+              <a:rPr sz="1150" b="0" i="0">
                 <a:solidFill>
                   <a:srgbClr val="51617F"/>
                 </a:solidFill>
                 <a:latin typeface="Arial"/>
               </a:rPr>
-              <a:t>bắt đầu từ pilot SHB → nhân rộng khối ngân hàng thương mại Việt Nam; cùng một lõi dùng được cho bảo hiểm, chứng khoán, công ty tài chính.</a:t>
+              <a:t>extractor riêng cho loại chứng từ layout ổn định</a:t>
+            </a:r>
+          </a:p>
+        </p:txBody>
+      </p:sp>
+      <p:sp>
+        <p:nvSpPr>
+          <p:cNvPr id="25" name="Right Arrow 24"/>
+          <p:cNvSpPr/>
+          <p:nvPr/>
+        </p:nvSpPr>
+        <p:spPr>
+          <a:xfrm>
+            <a:off x="3913632" y="2029968"/>
+            <a:ext cx="365760" cy="274320"/>
+          </a:xfrm>
+          <a:prstGeom prst="rightArrow">
+            <a:avLst/>
+          </a:prstGeom>
+          <a:solidFill>
+            <a:srgbClr val="F58220"/>
+          </a:solidFill>
+          <a:ln>
+            <a:noFill/>
+          </a:ln>
+          <a:effectLst/>
+        </p:spPr>
+        <p:style>
+          <a:lnRef idx="1">
+            <a:schemeClr val="accent1"/>
+          </a:lnRef>
+          <a:fillRef idx="3">
+            <a:schemeClr val="accent1"/>
+          </a:fillRef>
+          <a:effectRef idx="2">
+            <a:schemeClr val="accent1"/>
+          </a:effectRef>
+          <a:fontRef idx="minor">
+            <a:schemeClr val="lt1"/>
+          </a:fontRef>
+        </p:style>
+        <p:txBody>
+          <a:bodyPr rtlCol="0" anchor="ctr"/>
+          <a:lstStyle/>
+          <a:p>
+            <a:pPr algn="ctr"/>
+          </a:p>
+        </p:txBody>
+      </p:sp>
+      <p:sp>
+        <p:nvSpPr>
+          <p:cNvPr id="26" name="Down Arrow 25"/>
+          <p:cNvSpPr/>
+          <p:nvPr/>
+        </p:nvSpPr>
+        <p:spPr>
+          <a:xfrm>
+            <a:off x="5852160" y="2788920"/>
+            <a:ext cx="274320" cy="749808"/>
+          </a:xfrm>
+          <a:prstGeom prst="downArrow">
+            <a:avLst/>
+          </a:prstGeom>
+          <a:solidFill>
+            <a:srgbClr val="F58220"/>
+          </a:solidFill>
+          <a:ln>
+            <a:noFill/>
+          </a:ln>
+          <a:effectLst/>
+        </p:spPr>
+        <p:style>
+          <a:lnRef idx="1">
+            <a:schemeClr val="accent1"/>
+          </a:lnRef>
+          <a:fillRef idx="3">
+            <a:schemeClr val="accent1"/>
+          </a:fillRef>
+          <a:effectRef idx="2">
+            <a:schemeClr val="accent1"/>
+          </a:effectRef>
+          <a:fontRef idx="minor">
+            <a:schemeClr val="lt1"/>
+          </a:fontRef>
+        </p:style>
+        <p:txBody>
+          <a:bodyPr rtlCol="0" anchor="ctr"/>
+          <a:lstStyle/>
+          <a:p>
+            <a:pPr algn="ctr"/>
+          </a:p>
+        </p:txBody>
+      </p:sp>
+      <p:sp>
+        <p:nvSpPr>
+          <p:cNvPr id="27" name="Left Arrow 26"/>
+          <p:cNvSpPr/>
+          <p:nvPr/>
+        </p:nvSpPr>
+        <p:spPr>
+          <a:xfrm>
+            <a:off x="3913632" y="3995928"/>
+            <a:ext cx="365760" cy="274320"/>
+          </a:xfrm>
+          <a:prstGeom prst="leftArrow">
+            <a:avLst/>
+          </a:prstGeom>
+          <a:solidFill>
+            <a:srgbClr val="F58220"/>
+          </a:solidFill>
+          <a:ln>
+            <a:noFill/>
+          </a:ln>
+          <a:effectLst/>
+        </p:spPr>
+        <p:style>
+          <a:lnRef idx="1">
+            <a:schemeClr val="accent1"/>
+          </a:lnRef>
+          <a:fillRef idx="3">
+            <a:schemeClr val="accent1"/>
+          </a:fillRef>
+          <a:effectRef idx="2">
+            <a:schemeClr val="accent1"/>
+          </a:effectRef>
+          <a:fontRef idx="minor">
+            <a:schemeClr val="lt1"/>
+          </a:fontRef>
+        </p:style>
+        <p:txBody>
+          <a:bodyPr rtlCol="0" anchor="ctr"/>
+          <a:lstStyle/>
+          <a:p>
+            <a:pPr algn="ctr"/>
+          </a:p>
+        </p:txBody>
+      </p:sp>
+      <p:sp>
+        <p:nvSpPr>
+          <p:cNvPr id="28" name="Up Arrow 27"/>
+          <p:cNvSpPr/>
+          <p:nvPr/>
+        </p:nvSpPr>
+        <p:spPr>
+          <a:xfrm>
+            <a:off x="1965960" y="2788920"/>
+            <a:ext cx="274320" cy="749808"/>
+          </a:xfrm>
+          <a:prstGeom prst="upArrow">
+            <a:avLst/>
+          </a:prstGeom>
+          <a:solidFill>
+            <a:srgbClr val="F58220"/>
+          </a:solidFill>
+          <a:ln>
+            <a:noFill/>
+          </a:ln>
+          <a:effectLst/>
+        </p:spPr>
+        <p:style>
+          <a:lnRef idx="1">
+            <a:schemeClr val="accent1"/>
+          </a:lnRef>
+          <a:fillRef idx="3">
+            <a:schemeClr val="accent1"/>
+          </a:fillRef>
+          <a:effectRef idx="2">
+            <a:schemeClr val="accent1"/>
+          </a:effectRef>
+          <a:fontRef idx="minor">
+            <a:schemeClr val="lt1"/>
+          </a:fontRef>
+        </p:style>
+        <p:txBody>
+          <a:bodyPr rtlCol="0" anchor="ctr"/>
+          <a:lstStyle/>
+          <a:p>
+            <a:pPr algn="ctr"/>
+          </a:p>
+        </p:txBody>
+      </p:sp>
+      <p:sp>
+        <p:nvSpPr>
+          <p:cNvPr id="29" name="TextBox 28"/>
+          <p:cNvSpPr txBox="1"/>
+          <p:nvPr/>
+        </p:nvSpPr>
+        <p:spPr>
+          <a:xfrm>
+            <a:off x="2514600" y="2999232"/>
+            <a:ext cx="3017520" cy="365760"/>
+          </a:xfrm>
+          <a:prstGeom prst="rect">
+            <a:avLst/>
+          </a:prstGeom>
+          <a:noFill/>
+        </p:spPr>
+        <p:txBody>
+          <a:bodyPr wrap="square" anchor="t" lIns="0" rIns="0" tIns="0" bIns="0">
+            <a:spAutoFit/>
+          </a:bodyPr>
+          <a:lstStyle/>
+          <a:p>
+            <a:pPr algn="ctr">
+              <a:lnSpc>
+                <a:spcPct val="100000"/>
+              </a:lnSpc>
+              <a:spcAft>
+                <a:spcPts val="600"/>
+              </a:spcAft>
+            </a:pPr>
+            <a:r>
+              <a:rPr sz="1100" b="1" i="0">
+                <a:solidFill>
+                  <a:srgbClr val="C25605"/>
+                </a:solidFill>
+                <a:latin typeface="Arial"/>
+              </a:rPr>
+              <a:t>FLYWHEEL DỮ LIỆU</a:t>
+            </a:r>
+          </a:p>
+        </p:txBody>
+      </p:sp>
+      <p:sp>
+        <p:nvSpPr>
+          <p:cNvPr id="30" name="Rounded Rectangle 29"/>
+          <p:cNvSpPr/>
+          <p:nvPr/>
+        </p:nvSpPr>
+        <p:spPr>
+          <a:xfrm>
+            <a:off x="8001000" y="1645920"/>
+            <a:ext cx="3703320" cy="969264"/>
+          </a:xfrm>
+          <a:prstGeom prst="roundRect">
+            <a:avLst>
+              <a:gd name="adj" fmla="val 10000"/>
+            </a:avLst>
+          </a:prstGeom>
+          <a:solidFill>
+            <a:srgbClr val="0E1F3D"/>
+          </a:solidFill>
+          <a:ln>
+            <a:noFill/>
+          </a:ln>
+          <a:effectLst/>
+        </p:spPr>
+        <p:style>
+          <a:lnRef idx="1">
+            <a:schemeClr val="accent1"/>
+          </a:lnRef>
+          <a:fillRef idx="3">
+            <a:schemeClr val="accent1"/>
+          </a:fillRef>
+          <a:effectRef idx="2">
+            <a:schemeClr val="accent1"/>
+          </a:effectRef>
+          <a:fontRef idx="minor">
+            <a:schemeClr val="lt1"/>
+          </a:fontRef>
+        </p:style>
+        <p:txBody>
+          <a:bodyPr rtlCol="0" anchor="ctr"/>
+          <a:lstStyle/>
+          <a:p>
+            <a:pPr algn="ctr"/>
+          </a:p>
+        </p:txBody>
+      </p:sp>
+      <p:sp>
+        <p:nvSpPr>
+          <p:cNvPr id="31" name="TextBox 30"/>
+          <p:cNvSpPr txBox="1"/>
+          <p:nvPr/>
+        </p:nvSpPr>
+        <p:spPr>
+          <a:xfrm>
+            <a:off x="8229600" y="1737360"/>
+            <a:ext cx="3291840" cy="320040"/>
+          </a:xfrm>
+          <a:prstGeom prst="rect">
+            <a:avLst/>
+          </a:prstGeom>
+          <a:noFill/>
+        </p:spPr>
+        <p:txBody>
+          <a:bodyPr wrap="square" anchor="t" lIns="0" rIns="0" tIns="0" bIns="0">
+            <a:spAutoFit/>
+          </a:bodyPr>
+          <a:lstStyle/>
+          <a:p>
+            <a:pPr algn="l">
+              <a:lnSpc>
+                <a:spcPct val="100000"/>
+              </a:lnSpc>
+              <a:spcAft>
+                <a:spcPts val="600"/>
+              </a:spcAft>
+            </a:pPr>
+            <a:r>
+              <a:rPr sz="1350" b="1" i="0">
+                <a:solidFill>
+                  <a:srgbClr val="F58220"/>
+                </a:solidFill>
+                <a:latin typeface="Arial"/>
+              </a:rPr>
+              <a:t>On-prem</a:t>
+            </a:r>
+          </a:p>
+        </p:txBody>
+      </p:sp>
+      <p:sp>
+        <p:nvSpPr>
+          <p:cNvPr id="32" name="TextBox 31"/>
+          <p:cNvSpPr txBox="1"/>
+          <p:nvPr/>
+        </p:nvSpPr>
+        <p:spPr>
+          <a:xfrm>
+            <a:off x="8229600" y="2066544"/>
+            <a:ext cx="3291840" cy="502920"/>
+          </a:xfrm>
+          <a:prstGeom prst="rect">
+            <a:avLst/>
+          </a:prstGeom>
+          <a:noFill/>
+        </p:spPr>
+        <p:txBody>
+          <a:bodyPr wrap="square" anchor="t" lIns="0" rIns="0" tIns="0" bIns="0">
+            <a:spAutoFit/>
+          </a:bodyPr>
+          <a:lstStyle/>
+          <a:p>
+            <a:pPr algn="l">
+              <a:lnSpc>
+                <a:spcPct val="105000"/>
+              </a:lnSpc>
+              <a:spcAft>
+                <a:spcPts val="600"/>
+              </a:spcAft>
+            </a:pPr>
+            <a:r>
+              <a:rPr sz="1100" b="0" i="0">
+                <a:solidFill>
+                  <a:srgbClr val="B9C6DE"/>
+                </a:solidFill>
+                <a:latin typeface="Arial"/>
+              </a:rPr>
+              <a:t>dữ liệu không rời hạ tầng ngân hàng — điều API cloud không làm được</a:t>
+            </a:r>
+          </a:p>
+        </p:txBody>
+      </p:sp>
+      <p:sp>
+        <p:nvSpPr>
+          <p:cNvPr id="33" name="Rounded Rectangle 32"/>
+          <p:cNvSpPr/>
+          <p:nvPr/>
+        </p:nvSpPr>
+        <p:spPr>
+          <a:xfrm>
+            <a:off x="8001000" y="2761488"/>
+            <a:ext cx="3703320" cy="969264"/>
+          </a:xfrm>
+          <a:prstGeom prst="roundRect">
+            <a:avLst>
+              <a:gd name="adj" fmla="val 10000"/>
+            </a:avLst>
+          </a:prstGeom>
+          <a:solidFill>
+            <a:srgbClr val="0E1F3D"/>
+          </a:solidFill>
+          <a:ln>
+            <a:noFill/>
+          </a:ln>
+          <a:effectLst/>
+        </p:spPr>
+        <p:style>
+          <a:lnRef idx="1">
+            <a:schemeClr val="accent1"/>
+          </a:lnRef>
+          <a:fillRef idx="3">
+            <a:schemeClr val="accent1"/>
+          </a:fillRef>
+          <a:effectRef idx="2">
+            <a:schemeClr val="accent1"/>
+          </a:effectRef>
+          <a:fontRef idx="minor">
+            <a:schemeClr val="lt1"/>
+          </a:fontRef>
+        </p:style>
+        <p:txBody>
+          <a:bodyPr rtlCol="0" anchor="ctr"/>
+          <a:lstStyle/>
+          <a:p>
+            <a:pPr algn="ctr"/>
+          </a:p>
+        </p:txBody>
+      </p:sp>
+      <p:sp>
+        <p:nvSpPr>
+          <p:cNvPr id="34" name="TextBox 33"/>
+          <p:cNvSpPr txBox="1"/>
+          <p:nvPr/>
+        </p:nvSpPr>
+        <p:spPr>
+          <a:xfrm>
+            <a:off x="8229600" y="2852928"/>
+            <a:ext cx="3291840" cy="320040"/>
+          </a:xfrm>
+          <a:prstGeom prst="rect">
+            <a:avLst/>
+          </a:prstGeom>
+          <a:noFill/>
+        </p:spPr>
+        <p:txBody>
+          <a:bodyPr wrap="square" anchor="t" lIns="0" rIns="0" tIns="0" bIns="0">
+            <a:spAutoFit/>
+          </a:bodyPr>
+          <a:lstStyle/>
+          <a:p>
+            <a:pPr algn="l">
+              <a:lnSpc>
+                <a:spcPct val="100000"/>
+              </a:lnSpc>
+              <a:spcAft>
+                <a:spcPts val="600"/>
+              </a:spcAft>
+            </a:pPr>
+            <a:r>
+              <a:rPr sz="1350" b="1" i="0">
+                <a:solidFill>
+                  <a:srgbClr val="F58220"/>
+                </a:solidFill>
+                <a:latin typeface="Arial"/>
+              </a:rPr>
+              <a:t>Chi phí biên → 0</a:t>
+            </a:r>
+          </a:p>
+        </p:txBody>
+      </p:sp>
+      <p:sp>
+        <p:nvSpPr>
+          <p:cNvPr id="35" name="TextBox 34"/>
+          <p:cNvSpPr txBox="1"/>
+          <p:nvPr/>
+        </p:nvSpPr>
+        <p:spPr>
+          <a:xfrm>
+            <a:off x="8229600" y="3182112"/>
+            <a:ext cx="3291840" cy="502920"/>
+          </a:xfrm>
+          <a:prstGeom prst="rect">
+            <a:avLst/>
+          </a:prstGeom>
+          <a:noFill/>
+        </p:spPr>
+        <p:txBody>
+          <a:bodyPr wrap="square" anchor="t" lIns="0" rIns="0" tIns="0" bIns="0">
+            <a:spAutoFit/>
+          </a:bodyPr>
+          <a:lstStyle/>
+          <a:p>
+            <a:pPr algn="l">
+              <a:lnSpc>
+                <a:spcPct val="105000"/>
+              </a:lnSpc>
+              <a:spcAft>
+                <a:spcPts val="600"/>
+              </a:spcAft>
+            </a:pPr>
+            <a:r>
+              <a:rPr sz="1100" b="0" i="0">
+                <a:solidFill>
+                  <a:srgbClr val="B9C6DE"/>
+                </a:solidFill>
+                <a:latin typeface="Arial"/>
+              </a:rPr>
+              <a:t>loại chứng từ ổn định chạy model riêng, không tốn phí API theo lượt</a:t>
+            </a:r>
+          </a:p>
+        </p:txBody>
+      </p:sp>
+      <p:sp>
+        <p:nvSpPr>
+          <p:cNvPr id="36" name="Rounded Rectangle 35"/>
+          <p:cNvSpPr/>
+          <p:nvPr/>
+        </p:nvSpPr>
+        <p:spPr>
+          <a:xfrm>
+            <a:off x="8001000" y="3877056"/>
+            <a:ext cx="3703320" cy="969264"/>
+          </a:xfrm>
+          <a:prstGeom prst="roundRect">
+            <a:avLst>
+              <a:gd name="adj" fmla="val 10000"/>
+            </a:avLst>
+          </a:prstGeom>
+          <a:solidFill>
+            <a:srgbClr val="0E1F3D"/>
+          </a:solidFill>
+          <a:ln>
+            <a:noFill/>
+          </a:ln>
+          <a:effectLst/>
+        </p:spPr>
+        <p:style>
+          <a:lnRef idx="1">
+            <a:schemeClr val="accent1"/>
+          </a:lnRef>
+          <a:fillRef idx="3">
+            <a:schemeClr val="accent1"/>
+          </a:fillRef>
+          <a:effectRef idx="2">
+            <a:schemeClr val="accent1"/>
+          </a:effectRef>
+          <a:fontRef idx="minor">
+            <a:schemeClr val="lt1"/>
+          </a:fontRef>
+        </p:style>
+        <p:txBody>
+          <a:bodyPr rtlCol="0" anchor="ctr"/>
+          <a:lstStyle/>
+          <a:p>
+            <a:pPr algn="ctr"/>
+          </a:p>
+        </p:txBody>
+      </p:sp>
+      <p:sp>
+        <p:nvSpPr>
+          <p:cNvPr id="37" name="TextBox 36"/>
+          <p:cNvSpPr txBox="1"/>
+          <p:nvPr/>
+        </p:nvSpPr>
+        <p:spPr>
+          <a:xfrm>
+            <a:off x="8229600" y="3968496"/>
+            <a:ext cx="3291840" cy="320040"/>
+          </a:xfrm>
+          <a:prstGeom prst="rect">
+            <a:avLst/>
+          </a:prstGeom>
+          <a:noFill/>
+        </p:spPr>
+        <p:txBody>
+          <a:bodyPr wrap="square" anchor="t" lIns="0" rIns="0" tIns="0" bIns="0">
+            <a:spAutoFit/>
+          </a:bodyPr>
+          <a:lstStyle/>
+          <a:p>
+            <a:pPr algn="l">
+              <a:lnSpc>
+                <a:spcPct val="100000"/>
+              </a:lnSpc>
+              <a:spcAft>
+                <a:spcPts val="600"/>
+              </a:spcAft>
+            </a:pPr>
+            <a:r>
+              <a:rPr sz="1350" b="1" i="0">
+                <a:solidFill>
+                  <a:srgbClr val="F58220"/>
+                </a:solidFill>
+                <a:latin typeface="Arial"/>
+              </a:rPr>
+              <a:t>Gemini = lưới an toàn</a:t>
+            </a:r>
+          </a:p>
+        </p:txBody>
+      </p:sp>
+      <p:sp>
+        <p:nvSpPr>
+          <p:cNvPr id="38" name="TextBox 37"/>
+          <p:cNvSpPr txBox="1"/>
+          <p:nvPr/>
+        </p:nvSpPr>
+        <p:spPr>
+          <a:xfrm>
+            <a:off x="8229600" y="4297680"/>
+            <a:ext cx="3291840" cy="502920"/>
+          </a:xfrm>
+          <a:prstGeom prst="rect">
+            <a:avLst/>
+          </a:prstGeom>
+          <a:noFill/>
+        </p:spPr>
+        <p:txBody>
+          <a:bodyPr wrap="square" anchor="t" lIns="0" rIns="0" tIns="0" bIns="0">
+            <a:spAutoFit/>
+          </a:bodyPr>
+          <a:lstStyle/>
+          <a:p>
+            <a:pPr algn="l">
+              <a:lnSpc>
+                <a:spcPct val="105000"/>
+              </a:lnSpc>
+              <a:spcAft>
+                <a:spcPts val="600"/>
+              </a:spcAft>
+            </a:pPr>
+            <a:r>
+              <a:rPr sz="1100" b="0" i="0">
+                <a:solidFill>
+                  <a:srgbClr val="B9C6DE"/>
+                </a:solidFill>
+                <a:latin typeface="Arial"/>
+              </a:rPr>
+              <a:t>chỉ còn đọc ca khó: viết tay, mờ, loại giấy tờ mới</a:t>
+            </a:r>
+          </a:p>
+        </p:txBody>
+      </p:sp>
+      <p:sp>
+        <p:nvSpPr>
+          <p:cNvPr id="39" name="Rounded Rectangle 38"/>
+          <p:cNvSpPr/>
+          <p:nvPr/>
+        </p:nvSpPr>
+        <p:spPr>
+          <a:xfrm>
+            <a:off x="502920" y="5138928"/>
+            <a:ext cx="11201400" cy="960120"/>
+          </a:xfrm>
+          <a:prstGeom prst="roundRect">
+            <a:avLst>
+              <a:gd name="adj" fmla="val 12000"/>
+            </a:avLst>
+          </a:prstGeom>
+          <a:solidFill>
+            <a:srgbClr val="FFF7E6"/>
+          </a:solidFill>
+          <a:ln w="15240">
+            <a:solidFill>
+              <a:srgbClr val="F58220"/>
+            </a:solidFill>
+          </a:ln>
+          <a:effectLst/>
+        </p:spPr>
+        <p:style>
+          <a:lnRef idx="1">
+            <a:schemeClr val="accent1"/>
+          </a:lnRef>
+          <a:fillRef idx="3">
+            <a:schemeClr val="accent1"/>
+          </a:fillRef>
+          <a:effectRef idx="2">
+            <a:schemeClr val="accent1"/>
+          </a:effectRef>
+          <a:fontRef idx="minor">
+            <a:schemeClr val="lt1"/>
+          </a:fontRef>
+        </p:style>
+        <p:txBody>
+          <a:bodyPr rtlCol="0" anchor="ctr"/>
+          <a:lstStyle/>
+          <a:p>
+            <a:pPr algn="ctr"/>
+          </a:p>
+        </p:txBody>
+      </p:sp>
+      <p:sp>
+        <p:nvSpPr>
+          <p:cNvPr id="40" name="TextBox 39"/>
+          <p:cNvSpPr txBox="1"/>
+          <p:nvPr/>
+        </p:nvSpPr>
+        <p:spPr>
+          <a:xfrm>
+            <a:off x="868680" y="5376672"/>
+            <a:ext cx="10515600" cy="640080"/>
+          </a:xfrm>
+          <a:prstGeom prst="rect">
+            <a:avLst/>
+          </a:prstGeom>
+          <a:noFill/>
+        </p:spPr>
+        <p:txBody>
+          <a:bodyPr wrap="square" anchor="t" lIns="0" rIns="0" tIns="0" bIns="0">
+            <a:spAutoFit/>
+          </a:bodyPr>
+          <a:lstStyle/>
+          <a:p>
+            <a:pPr algn="ctr">
+              <a:lnSpc>
+                <a:spcPct val="100000"/>
+              </a:lnSpc>
+              <a:spcAft>
+                <a:spcPts val="600"/>
+              </a:spcAft>
+            </a:pPr>
+            <a:r>
+              <a:rPr sz="1800" b="1" i="0">
+                <a:solidFill>
+                  <a:srgbClr val="C25605"/>
+                </a:solidFill>
+                <a:latin typeface="Arial"/>
+              </a:rPr>
+              <a:t>“Tụi em không chọn giữa LLM và PyTorch — tụi em dùng LLM để bootstrap PyTorch.”</a:t>
             </a:r>
           </a:p>
         </p:txBody>

</xml_diff>

<commit_message>
Deck: sửa title slide 3 tràn 2 dòng đâm đường kẻ header, siết khối bullet kiến trúc, gọn hộp tagline cover
Co-Authored-By: Claude Fable 5 <noreply@anthropic.com>
</commit_message>
<xml_diff>
--- a/docs/DocFlow-pitch-DemoDay.pptx
+++ b/docs/DocFlow-pitch-DemoDay.pptx
@@ -4481,7 +4481,7 @@
         <p:spPr>
           <a:xfrm>
             <a:off x="521207" y="3429000"/>
-            <a:ext cx="10515600" cy="914400"/>
+            <a:ext cx="10515600" cy="502920"/>
           </a:xfrm>
           <a:prstGeom prst="rect">
             <a:avLst/>
@@ -7484,7 +7484,7 @@
                 </a:solidFill>
                 <a:latin typeface="Arial"/>
               </a:rPr>
-              <a:t>Thả cả bộ hồ sơ vào — phần còn lại là một luồng duy nhất</a:t>
+              <a:t>Thả hồ sơ vào — còn lại là một luồng duy nhất</a:t>
             </a:r>
           </a:p>
         </p:txBody>
@@ -11503,8 +11503,8 @@
         </p:nvSpPr>
         <p:spPr>
           <a:xfrm>
-            <a:off x="502920" y="4846320"/>
-            <a:ext cx="11155680" cy="1371600"/>
+            <a:off x="502920" y="4754880"/>
+            <a:ext cx="11155680" cy="1463040"/>
           </a:xfrm>
           <a:prstGeom prst="rect">
             <a:avLst/>
@@ -11519,14 +11519,14 @@
           <a:p>
             <a:pPr algn="l">
               <a:lnSpc>
-                <a:spcPct val="125000"/>
+                <a:spcPct val="118000"/>
               </a:lnSpc>
               <a:spcAft>
                 <a:spcPts val="600"/>
               </a:spcAft>
             </a:pPr>
             <a:r>
-              <a:rPr sz="1550" b="1" i="0">
+              <a:rPr sz="1500" b="1" i="0">
                 <a:solidFill>
                   <a:srgbClr val="0E1F3D"/>
                 </a:solidFill>
@@ -11535,7 +11535,7 @@
               <a:t>Không một credential file nào tồn tại trong hệ thống</a:t>
             </a:r>
             <a:r>
-              <a:rPr sz="1550" b="0" i="0">
+              <a:rPr sz="1500" b="0" i="0">
                 <a:solidFill>
                   <a:srgbClr val="51617F"/>
                 </a:solidFill>
@@ -11547,14 +11547,14 @@
           <a:p>
             <a:pPr algn="l">
               <a:lnSpc>
-                <a:spcPct val="125000"/>
+                <a:spcPct val="118000"/>
               </a:lnSpc>
               <a:spcAft>
                 <a:spcPts val="600"/>
               </a:spcAft>
             </a:pPr>
             <a:r>
-              <a:rPr sz="1550" b="1" i="0">
+              <a:rPr sz="1500" b="1" i="0">
                 <a:solidFill>
                   <a:srgbClr val="0E1F3D"/>
                 </a:solidFill>
@@ -11563,26 +11563,26 @@
               <a:t>100% code AI sinh trong 48h</a:t>
             </a:r>
             <a:r>
-              <a:rPr sz="1550" b="0" i="0">
+              <a:rPr sz="1500" b="0" i="0">
                 <a:solidFill>
                   <a:srgbClr val="51617F"/>
                 </a:solidFill>
                 <a:latin typeface="Arial"/>
               </a:rPr>
-              <a:t> — nhật ký cộng tác AI đầy đủ 7 phiên (AI-LOG.md + session files).</a:t>
+              <a:t> — nhật ký cộng tác AI đầy đủ (AI-LOG.md + session files).</a:t>
             </a:r>
           </a:p>
           <a:p>
             <a:pPr algn="l">
               <a:lnSpc>
-                <a:spcPct val="125000"/>
+                <a:spcPct val="118000"/>
               </a:lnSpc>
               <a:spcAft>
                 <a:spcPts val="600"/>
               </a:spcAft>
             </a:pPr>
             <a:r>
-              <a:rPr sz="1550" b="1" i="0">
+              <a:rPr sz="1500" b="1" i="0">
                 <a:solidFill>
                   <a:srgbClr val="0E1F3D"/>
                 </a:solidFill>
@@ -11591,7 +11591,7 @@
               <a:t>Chi phí tuyến tính theo trang</a:t>
             </a:r>
             <a:r>
-              <a:rPr sz="1550" b="0" i="0">
+              <a:rPr sz="1500" b="0" i="0">
                 <a:solidFill>
                   <a:srgbClr val="51617F"/>
                 </a:solidFill>

</xml_diff>

<commit_message>
Deck: tắt word-wrap chevron slide 3 — hết bẻ chữ giữa từ (soát bằng PDF render thật)
Co-Authored-By: Claude Fable 5 <noreply@anthropic.com>
</commit_message>
<xml_diff>
--- a/docs/DocFlow-pitch-DemoDay.pptx
+++ b/docs/DocFlow-pitch-DemoDay.pptx
@@ -7654,7 +7654,7 @@
           </a:fontRef>
         </p:style>
         <p:txBody>
-          <a:bodyPr rtlCol="0" anchor="ctr" wrap="square" lIns="256032" rIns="45720"/>
+          <a:bodyPr rtlCol="0" anchor="ctr" wrap="none" lIns="256032" rIns="45720"/>
           <a:lstStyle/>
           <a:p>
             <a:pPr algn="ctr"/>
@@ -7707,7 +7707,7 @@
           </a:fontRef>
         </p:style>
         <p:txBody>
-          <a:bodyPr rtlCol="0" anchor="ctr" wrap="square" lIns="256032" rIns="45720"/>
+          <a:bodyPr rtlCol="0" anchor="ctr" wrap="none" lIns="256032" rIns="45720"/>
           <a:lstStyle/>
           <a:p>
             <a:pPr algn="ctr"/>
@@ -7772,7 +7772,7 @@
           </a:fontRef>
         </p:style>
         <p:txBody>
-          <a:bodyPr rtlCol="0" anchor="ctr" wrap="square" lIns="256032" rIns="45720"/>
+          <a:bodyPr rtlCol="0" anchor="ctr" wrap="none" lIns="256032" rIns="45720"/>
           <a:lstStyle/>
           <a:p>
             <a:pPr algn="ctr"/>
@@ -7837,7 +7837,7 @@
           </a:fontRef>
         </p:style>
         <p:txBody>
-          <a:bodyPr rtlCol="0" anchor="ctr" wrap="square" lIns="256032" rIns="45720"/>
+          <a:bodyPr rtlCol="0" anchor="ctr" wrap="none" lIns="256032" rIns="45720"/>
           <a:lstStyle/>
           <a:p>
             <a:pPr algn="ctr"/>
@@ -7902,7 +7902,7 @@
           </a:fontRef>
         </p:style>
         <p:txBody>
-          <a:bodyPr rtlCol="0" anchor="ctr" wrap="square" lIns="256032" rIns="45720"/>
+          <a:bodyPr rtlCol="0" anchor="ctr" wrap="none" lIns="256032" rIns="45720"/>
           <a:lstStyle/>
           <a:p>
             <a:pPr algn="ctr"/>

</xml_diff>